<commit_message>
Update ERS deck 05 listings to the current validator, port and handler code
</commit_message>
<xml_diff>
--- a/01 Elementi Razvoja Softvera/02 Prezentacije/PPTX/05_Integracija_modula_ugovori.pptx
+++ b/01 Elementi Razvoja Softvera/02 Prezentacije/PPTX/05_Integracija_modula_ugovori.pptx
@@ -6428,13 +6428,46 @@
             <a:r>
               <a:rPr sz="980" b="1">
                 <a:solidFill>
+                  <a:srgbClr val="0563C1"/>
+                </a:solidFill>
+                <a:latin typeface="Consolas"/>
+                <a:ea typeface="Consolas"/>
+                <a:cs typeface="Consolas"/>
+              </a:rPr>
+              <a:t>var</a:t>
+            </a:r>
+            <a:r>
+              <a:rPr sz="980" b="0">
+                <a:solidFill>
+                  <a:srgbClr val="202632"/>
+                </a:solidFill>
+                <a:latin typeface="Consolas"/>
+                <a:ea typeface="Consolas"/>
+                <a:cs typeface="Consolas"/>
+              </a:rPr>
+              <a:t> validation = _validator.</a:t>
+            </a:r>
+            <a:r>
+              <a:rPr sz="980" b="1">
+                <a:solidFill>
                   <a:srgbClr val="7F3FBF"/>
                 </a:solidFill>
                 <a:latin typeface="Consolas"/>
                 <a:ea typeface="Consolas"/>
                 <a:cs typeface="Consolas"/>
               </a:rPr>
-              <a:t>CreateReservationCommandValidator</a:t>
+              <a:t>Validate</a:t>
+            </a:r>
+            <a:r>
+              <a:rPr sz="980" b="0">
+                <a:solidFill>
+                  <a:srgbClr val="202632"/>
+                </a:solidFill>
+                <a:latin typeface="Consolas"/>
+                <a:ea typeface="Consolas"/>
+                <a:cs typeface="Consolas"/>
+              </a:rPr>
+              <a:t>(command);</a:t>
             </a:r>
             <a:br/>
             <a:r>
@@ -6449,6 +6482,17 @@
               <a:t> 2  </a:t>
             </a:r>
             <a:r>
+              <a:rPr sz="980" b="1">
+                <a:solidFill>
+                  <a:srgbClr val="0563C1"/>
+                </a:solidFill>
+                <a:latin typeface="Consolas"/>
+                <a:ea typeface="Consolas"/>
+                <a:cs typeface="Consolas"/>
+              </a:rPr>
+              <a:t>if</a:t>
+            </a:r>
+            <a:r>
               <a:rPr sz="980" b="0">
                 <a:solidFill>
                   <a:srgbClr val="202632"/>
@@ -6457,6 +6501,252 @@
                 <a:ea typeface="Consolas"/>
                 <a:cs typeface="Consolas"/>
               </a:rPr>
+              <a:t> (!validation.</a:t>
+            </a:r>
+            <a:r>
+              <a:rPr sz="980" b="1">
+                <a:solidFill>
+                  <a:srgbClr val="7F3FBF"/>
+                </a:solidFill>
+                <a:latin typeface="Consolas"/>
+                <a:ea typeface="Consolas"/>
+                <a:cs typeface="Consolas"/>
+              </a:rPr>
+              <a:t>Success</a:t>
+            </a:r>
+            <a:r>
+              <a:rPr sz="980" b="0">
+                <a:solidFill>
+                  <a:srgbClr val="202632"/>
+                </a:solidFill>
+                <a:latin typeface="Consolas"/>
+                <a:ea typeface="Consolas"/>
+                <a:cs typeface="Consolas"/>
+              </a:rPr>
+              <a:t>)</a:t>
+            </a:r>
+            <a:br/>
+            <a:r>
+              <a:rPr sz="980">
+                <a:solidFill>
+                  <a:srgbClr val="7A8699"/>
+                </a:solidFill>
+                <a:latin typeface="Consolas"/>
+                <a:ea typeface="Consolas"/>
+                <a:cs typeface="Consolas"/>
+              </a:rPr>
+              <a:t> 3  </a:t>
+            </a:r>
+            <a:r>
+              <a:rPr sz="980" b="0">
+                <a:solidFill>
+                  <a:srgbClr val="202632"/>
+                </a:solidFill>
+                <a:latin typeface="Consolas"/>
+                <a:ea typeface="Consolas"/>
+                <a:cs typeface="Consolas"/>
+              </a:rPr>
+              <a:t>  </a:t>
+            </a:r>
+            <a:r>
+              <a:rPr sz="980" b="1">
+                <a:solidFill>
+                  <a:srgbClr val="0563C1"/>
+                </a:solidFill>
+                <a:latin typeface="Consolas"/>
+                <a:ea typeface="Consolas"/>
+                <a:cs typeface="Consolas"/>
+              </a:rPr>
+              <a:t>return</a:t>
+            </a:r>
+            <a:r>
+              <a:rPr sz="980" b="0">
+                <a:solidFill>
+                  <a:srgbClr val="202632"/>
+                </a:solidFill>
+                <a:latin typeface="Consolas"/>
+                <a:ea typeface="Consolas"/>
+                <a:cs typeface="Consolas"/>
+              </a:rPr>
+              <a:t> </a:t>
+            </a:r>
+            <a:r>
+              <a:rPr sz="980" b="1">
+                <a:solidFill>
+                  <a:srgbClr val="7F3FBF"/>
+                </a:solidFill>
+                <a:latin typeface="Consolas"/>
+                <a:ea typeface="Consolas"/>
+                <a:cs typeface="Consolas"/>
+              </a:rPr>
+              <a:t>CreateReservationResult</a:t>
+            </a:r>
+            <a:r>
+              <a:rPr sz="980" b="0">
+                <a:solidFill>
+                  <a:srgbClr val="202632"/>
+                </a:solidFill>
+                <a:latin typeface="Consolas"/>
+                <a:ea typeface="Consolas"/>
+                <a:cs typeface="Consolas"/>
+              </a:rPr>
+              <a:t>.</a:t>
+            </a:r>
+            <a:r>
+              <a:rPr sz="980" b="1">
+                <a:solidFill>
+                  <a:srgbClr val="7F3FBF"/>
+                </a:solidFill>
+                <a:latin typeface="Consolas"/>
+                <a:ea typeface="Consolas"/>
+                <a:cs typeface="Consolas"/>
+              </a:rPr>
+              <a:t>Invalid</a:t>
+            </a:r>
+            <a:r>
+              <a:rPr sz="980" b="0">
+                <a:solidFill>
+                  <a:srgbClr val="202632"/>
+                </a:solidFill>
+                <a:latin typeface="Consolas"/>
+                <a:ea typeface="Consolas"/>
+                <a:cs typeface="Consolas"/>
+              </a:rPr>
+              <a:t>(validation.</a:t>
+            </a:r>
+            <a:r>
+              <a:rPr sz="980" b="1">
+                <a:solidFill>
+                  <a:srgbClr val="7F3FBF"/>
+                </a:solidFill>
+                <a:latin typeface="Consolas"/>
+                <a:ea typeface="Consolas"/>
+                <a:cs typeface="Consolas"/>
+              </a:rPr>
+              <a:t>Error</a:t>
+            </a:r>
+            <a:r>
+              <a:rPr sz="980" b="0">
+                <a:solidFill>
+                  <a:srgbClr val="202632"/>
+                </a:solidFill>
+                <a:latin typeface="Consolas"/>
+                <a:ea typeface="Consolas"/>
+                <a:cs typeface="Consolas"/>
+              </a:rPr>
+              <a:t>);</a:t>
+            </a:r>
+            <a:br/>
+            <a:r>
+              <a:rPr sz="980">
+                <a:solidFill>
+                  <a:srgbClr val="7A8699"/>
+                </a:solidFill>
+                <a:latin typeface="Consolas"/>
+                <a:ea typeface="Consolas"/>
+                <a:cs typeface="Consolas"/>
+              </a:rPr>
+              <a:t> 4  </a:t>
+            </a:r>
+            <a:br/>
+            <a:r>
+              <a:rPr sz="980">
+                <a:solidFill>
+                  <a:srgbClr val="7A8699"/>
+                </a:solidFill>
+                <a:latin typeface="Consolas"/>
+                <a:ea typeface="Consolas"/>
+                <a:cs typeface="Consolas"/>
+              </a:rPr>
+              <a:t> 5  </a:t>
+            </a:r>
+            <a:r>
+              <a:rPr sz="980" b="1">
+                <a:solidFill>
+                  <a:srgbClr val="0563C1"/>
+                </a:solidFill>
+                <a:latin typeface="Consolas"/>
+                <a:ea typeface="Consolas"/>
+                <a:cs typeface="Consolas"/>
+              </a:rPr>
+              <a:t>await</a:t>
+            </a:r>
+            <a:r>
+              <a:rPr sz="980" b="0">
+                <a:solidFill>
+                  <a:srgbClr val="202632"/>
+                </a:solidFill>
+                <a:latin typeface="Consolas"/>
+                <a:ea typeface="Consolas"/>
+                <a:cs typeface="Consolas"/>
+              </a:rPr>
+              <a:t> using </a:t>
+            </a:r>
+            <a:r>
+              <a:rPr sz="980" b="1">
+                <a:solidFill>
+                  <a:srgbClr val="0563C1"/>
+                </a:solidFill>
+                <a:latin typeface="Consolas"/>
+                <a:ea typeface="Consolas"/>
+                <a:cs typeface="Consolas"/>
+              </a:rPr>
+              <a:t>var</a:t>
+            </a:r>
+            <a:r>
+              <a:rPr sz="980" b="0">
+                <a:solidFill>
+                  <a:srgbClr val="202632"/>
+                </a:solidFill>
+                <a:latin typeface="Consolas"/>
+                <a:ea typeface="Consolas"/>
+                <a:cs typeface="Consolas"/>
+              </a:rPr>
+              <a:t> lease = </a:t>
+            </a:r>
+            <a:r>
+              <a:rPr sz="980" b="1">
+                <a:solidFill>
+                  <a:srgbClr val="0563C1"/>
+                </a:solidFill>
+                <a:latin typeface="Consolas"/>
+                <a:ea typeface="Consolas"/>
+                <a:cs typeface="Consolas"/>
+              </a:rPr>
+              <a:t>await</a:t>
+            </a:r>
+            <a:r>
+              <a:rPr sz="980" b="0">
+                <a:solidFill>
+                  <a:srgbClr val="202632"/>
+                </a:solidFill>
+                <a:latin typeface="Consolas"/>
+                <a:ea typeface="Consolas"/>
+                <a:cs typeface="Consolas"/>
+              </a:rPr>
+              <a:t> _requestLock</a:t>
+            </a:r>
+            <a:br/>
+            <a:r>
+              <a:rPr sz="980">
+                <a:solidFill>
+                  <a:srgbClr val="7A8699"/>
+                </a:solidFill>
+                <a:latin typeface="Consolas"/>
+                <a:ea typeface="Consolas"/>
+                <a:cs typeface="Consolas"/>
+              </a:rPr>
+              <a:t> 6  </a:t>
+            </a:r>
+            <a:r>
+              <a:rPr sz="980" b="0">
+                <a:solidFill>
+                  <a:srgbClr val="202632"/>
+                </a:solidFill>
+                <a:latin typeface="Consolas"/>
+                <a:ea typeface="Consolas"/>
+                <a:cs typeface="Consolas"/>
+              </a:rPr>
               <a:t>  .</a:t>
             </a:r>
             <a:r>
@@ -6468,7 +6758,7 @@
                 <a:ea typeface="Consolas"/>
                 <a:cs typeface="Consolas"/>
               </a:rPr>
-              <a:t>ValidateAndThrow</a:t>
+              <a:t>AcquireAsync</a:t>
             </a:r>
             <a:r>
               <a:rPr sz="980" b="0">
@@ -6479,7 +6769,29 @@
                 <a:ea typeface="Consolas"/>
                 <a:cs typeface="Consolas"/>
               </a:rPr>
-              <a:t>(command);</a:t>
+              <a:t>(command.</a:t>
+            </a:r>
+            <a:r>
+              <a:rPr sz="980" b="1">
+                <a:solidFill>
+                  <a:srgbClr val="7F3FBF"/>
+                </a:solidFill>
+                <a:latin typeface="Consolas"/>
+                <a:ea typeface="Consolas"/>
+                <a:cs typeface="Consolas"/>
+              </a:rPr>
+              <a:t>RequestId</a:t>
+            </a:r>
+            <a:r>
+              <a:rPr sz="980" b="0">
+                <a:solidFill>
+                  <a:srgbClr val="202632"/>
+                </a:solidFill>
+                <a:latin typeface="Consolas"/>
+                <a:ea typeface="Consolas"/>
+                <a:cs typeface="Consolas"/>
+              </a:rPr>
+              <a:t>, ct);</a:t>
             </a:r>
             <a:br/>
             <a:r>
@@ -6491,7 +6803,7 @@
                 <a:ea typeface="Consolas"/>
                 <a:cs typeface="Consolas"/>
               </a:rPr>
-              <a:t> 3  </a:t>
+              <a:t> 7  </a:t>
             </a:r>
             <a:r>
               <a:rPr sz="980" b="1">
@@ -6502,6 +6814,28 @@
                 <a:ea typeface="Consolas"/>
                 <a:cs typeface="Consolas"/>
               </a:rPr>
+              <a:t>var</a:t>
+            </a:r>
+            <a:r>
+              <a:rPr sz="980" b="0">
+                <a:solidFill>
+                  <a:srgbClr val="202632"/>
+                </a:solidFill>
+                <a:latin typeface="Consolas"/>
+                <a:ea typeface="Consolas"/>
+                <a:cs typeface="Consolas"/>
+              </a:rPr>
+              <a:t> existing = </a:t>
+            </a:r>
+            <a:r>
+              <a:rPr sz="980" b="1">
+                <a:solidFill>
+                  <a:srgbClr val="0563C1"/>
+                </a:solidFill>
+                <a:latin typeface="Consolas"/>
+                <a:ea typeface="Consolas"/>
+                <a:cs typeface="Consolas"/>
+              </a:rPr>
               <a:t>await</a:t>
             </a:r>
             <a:r>
@@ -6513,17 +6847,319 @@
                 <a:ea typeface="Consolas"/>
                 <a:cs typeface="Consolas"/>
               </a:rPr>
-              <a:t> using </a:t>
+              <a:t> _reservations</a:t>
+            </a:r>
+            <a:br/>
+            <a:r>
+              <a:rPr sz="980">
+                <a:solidFill>
+                  <a:srgbClr val="7A8699"/>
+                </a:solidFill>
+                <a:latin typeface="Consolas"/>
+                <a:ea typeface="Consolas"/>
+                <a:cs typeface="Consolas"/>
+              </a:rPr>
+              <a:t> 8  </a:t>
+            </a:r>
+            <a:r>
+              <a:rPr sz="980" b="0">
+                <a:solidFill>
+                  <a:srgbClr val="202632"/>
+                </a:solidFill>
+                <a:latin typeface="Consolas"/>
+                <a:ea typeface="Consolas"/>
+                <a:cs typeface="Consolas"/>
+              </a:rPr>
+              <a:t>  .</a:t>
             </a:r>
             <a:r>
               <a:rPr sz="980" b="1">
                 <a:solidFill>
+                  <a:srgbClr val="7F3FBF"/>
+                </a:solidFill>
+                <a:latin typeface="Consolas"/>
+                <a:ea typeface="Consolas"/>
+                <a:cs typeface="Consolas"/>
+              </a:rPr>
+              <a:t>FindByRequestIdAsync</a:t>
+            </a:r>
+            <a:r>
+              <a:rPr sz="980" b="0">
+                <a:solidFill>
+                  <a:srgbClr val="202632"/>
+                </a:solidFill>
+                <a:latin typeface="Consolas"/>
+                <a:ea typeface="Consolas"/>
+                <a:cs typeface="Consolas"/>
+              </a:rPr>
+              <a:t>(command.</a:t>
+            </a:r>
+            <a:r>
+              <a:rPr sz="980" b="1">
+                <a:solidFill>
+                  <a:srgbClr val="7F3FBF"/>
+                </a:solidFill>
+                <a:latin typeface="Consolas"/>
+                <a:ea typeface="Consolas"/>
+                <a:cs typeface="Consolas"/>
+              </a:rPr>
+              <a:t>RequestId</a:t>
+            </a:r>
+            <a:r>
+              <a:rPr sz="980" b="0">
+                <a:solidFill>
+                  <a:srgbClr val="202632"/>
+                </a:solidFill>
+                <a:latin typeface="Consolas"/>
+                <a:ea typeface="Consolas"/>
+                <a:cs typeface="Consolas"/>
+              </a:rPr>
+              <a:t>, ct);</a:t>
+            </a:r>
+            <a:br/>
+            <a:r>
+              <a:rPr sz="980">
+                <a:solidFill>
+                  <a:srgbClr val="7A8699"/>
+                </a:solidFill>
+                <a:latin typeface="Consolas"/>
+                <a:ea typeface="Consolas"/>
+                <a:cs typeface="Consolas"/>
+              </a:rPr>
+              <a:t> 9  </a:t>
+            </a:r>
+            <a:r>
+              <a:rPr sz="980" b="1">
+                <a:solidFill>
                   <a:srgbClr val="0563C1"/>
                 </a:solidFill>
                 <a:latin typeface="Consolas"/>
                 <a:ea typeface="Consolas"/>
                 <a:cs typeface="Consolas"/>
               </a:rPr>
+              <a:t>if</a:t>
+            </a:r>
+            <a:r>
+              <a:rPr sz="980" b="0">
+                <a:solidFill>
+                  <a:srgbClr val="202632"/>
+                </a:solidFill>
+                <a:latin typeface="Consolas"/>
+                <a:ea typeface="Consolas"/>
+                <a:cs typeface="Consolas"/>
+              </a:rPr>
+              <a:t> (existing </a:t>
+            </a:r>
+            <a:r>
+              <a:rPr sz="980" b="1">
+                <a:solidFill>
+                  <a:srgbClr val="0563C1"/>
+                </a:solidFill>
+                <a:latin typeface="Consolas"/>
+                <a:ea typeface="Consolas"/>
+                <a:cs typeface="Consolas"/>
+              </a:rPr>
+              <a:t>is</a:t>
+            </a:r>
+            <a:r>
+              <a:rPr sz="980" b="0">
+                <a:solidFill>
+                  <a:srgbClr val="202632"/>
+                </a:solidFill>
+                <a:latin typeface="Consolas"/>
+                <a:ea typeface="Consolas"/>
+                <a:cs typeface="Consolas"/>
+              </a:rPr>
+              <a:t> </a:t>
+            </a:r>
+            <a:r>
+              <a:rPr sz="980" b="1">
+                <a:solidFill>
+                  <a:srgbClr val="0563C1"/>
+                </a:solidFill>
+                <a:latin typeface="Consolas"/>
+                <a:ea typeface="Consolas"/>
+                <a:cs typeface="Consolas"/>
+              </a:rPr>
+              <a:t>not</a:t>
+            </a:r>
+            <a:r>
+              <a:rPr sz="980" b="0">
+                <a:solidFill>
+                  <a:srgbClr val="202632"/>
+                </a:solidFill>
+                <a:latin typeface="Consolas"/>
+                <a:ea typeface="Consolas"/>
+                <a:cs typeface="Consolas"/>
+              </a:rPr>
+              <a:t> </a:t>
+            </a:r>
+            <a:r>
+              <a:rPr sz="980" b="1">
+                <a:solidFill>
+                  <a:srgbClr val="0563C1"/>
+                </a:solidFill>
+                <a:latin typeface="Consolas"/>
+                <a:ea typeface="Consolas"/>
+                <a:cs typeface="Consolas"/>
+              </a:rPr>
+              <a:t>null</a:t>
+            </a:r>
+            <a:r>
+              <a:rPr sz="980" b="0">
+                <a:solidFill>
+                  <a:srgbClr val="202632"/>
+                </a:solidFill>
+                <a:latin typeface="Consolas"/>
+                <a:ea typeface="Consolas"/>
+                <a:cs typeface="Consolas"/>
+              </a:rPr>
+              <a:t>)</a:t>
+            </a:r>
+            <a:br/>
+            <a:r>
+              <a:rPr sz="980">
+                <a:solidFill>
+                  <a:srgbClr val="7A8699"/>
+                </a:solidFill>
+                <a:latin typeface="Consolas"/>
+                <a:ea typeface="Consolas"/>
+                <a:cs typeface="Consolas"/>
+              </a:rPr>
+              <a:t>10  </a:t>
+            </a:r>
+            <a:r>
+              <a:rPr sz="980" b="0">
+                <a:solidFill>
+                  <a:srgbClr val="202632"/>
+                </a:solidFill>
+                <a:latin typeface="Consolas"/>
+                <a:ea typeface="Consolas"/>
+                <a:cs typeface="Consolas"/>
+              </a:rPr>
+              <a:t>  </a:t>
+            </a:r>
+            <a:r>
+              <a:rPr sz="980" b="1">
+                <a:solidFill>
+                  <a:srgbClr val="0563C1"/>
+                </a:solidFill>
+                <a:latin typeface="Consolas"/>
+                <a:ea typeface="Consolas"/>
+                <a:cs typeface="Consolas"/>
+              </a:rPr>
+              <a:t>return</a:t>
+            </a:r>
+            <a:r>
+              <a:rPr sz="980" b="0">
+                <a:solidFill>
+                  <a:srgbClr val="202632"/>
+                </a:solidFill>
+                <a:latin typeface="Consolas"/>
+                <a:ea typeface="Consolas"/>
+                <a:cs typeface="Consolas"/>
+              </a:rPr>
+              <a:t> </a:t>
+            </a:r>
+            <a:r>
+              <a:rPr sz="980" b="1">
+                <a:solidFill>
+                  <a:srgbClr val="7F3FBF"/>
+                </a:solidFill>
+                <a:latin typeface="Consolas"/>
+                <a:ea typeface="Consolas"/>
+                <a:cs typeface="Consolas"/>
+              </a:rPr>
+              <a:t>CreateReservationResult</a:t>
+            </a:r>
+            <a:r>
+              <a:rPr sz="980" b="0">
+                <a:solidFill>
+                  <a:srgbClr val="202632"/>
+                </a:solidFill>
+                <a:latin typeface="Consolas"/>
+                <a:ea typeface="Consolas"/>
+                <a:cs typeface="Consolas"/>
+              </a:rPr>
+              <a:t>.</a:t>
+            </a:r>
+            <a:r>
+              <a:rPr sz="980" b="1">
+                <a:solidFill>
+                  <a:srgbClr val="7F3FBF"/>
+                </a:solidFill>
+                <a:latin typeface="Consolas"/>
+                <a:ea typeface="Consolas"/>
+                <a:cs typeface="Consolas"/>
+              </a:rPr>
+              <a:t>From</a:t>
+            </a:r>
+            <a:r>
+              <a:rPr sz="980" b="0">
+                <a:solidFill>
+                  <a:srgbClr val="202632"/>
+                </a:solidFill>
+                <a:latin typeface="Consolas"/>
+                <a:ea typeface="Consolas"/>
+                <a:cs typeface="Consolas"/>
+              </a:rPr>
+              <a:t>(existing, replayed: </a:t>
+            </a:r>
+            <a:r>
+              <a:rPr sz="980" b="1">
+                <a:solidFill>
+                  <a:srgbClr val="0563C1"/>
+                </a:solidFill>
+                <a:latin typeface="Consolas"/>
+                <a:ea typeface="Consolas"/>
+                <a:cs typeface="Consolas"/>
+              </a:rPr>
+              <a:t>true</a:t>
+            </a:r>
+            <a:r>
+              <a:rPr sz="980" b="0">
+                <a:solidFill>
+                  <a:srgbClr val="202632"/>
+                </a:solidFill>
+                <a:latin typeface="Consolas"/>
+                <a:ea typeface="Consolas"/>
+                <a:cs typeface="Consolas"/>
+              </a:rPr>
+              <a:t>);</a:t>
+            </a:r>
+            <a:br/>
+            <a:r>
+              <a:rPr sz="980">
+                <a:solidFill>
+                  <a:srgbClr val="7A8699"/>
+                </a:solidFill>
+                <a:latin typeface="Consolas"/>
+                <a:ea typeface="Consolas"/>
+                <a:cs typeface="Consolas"/>
+              </a:rPr>
+              <a:t>11  </a:t>
+            </a:r>
+            <a:br/>
+            <a:r>
+              <a:rPr sz="980">
+                <a:solidFill>
+                  <a:srgbClr val="7A8699"/>
+                </a:solidFill>
+                <a:latin typeface="Consolas"/>
+                <a:ea typeface="Consolas"/>
+                <a:cs typeface="Consolas"/>
+              </a:rPr>
+              <a:t>12  </a:t>
+            </a:r>
+            <a:r>
+              <a:rPr sz="980" b="1">
+                <a:solidFill>
+                  <a:srgbClr val="0563C1"/>
+                </a:solidFill>
+                <a:latin typeface="Consolas"/>
+                <a:ea typeface="Consolas"/>
+                <a:cs typeface="Consolas"/>
+              </a:rPr>
               <a:t>var</a:t>
             </a:r>
             <a:r>
@@ -6535,17 +7171,73 @@
                 <a:ea typeface="Consolas"/>
                 <a:cs typeface="Consolas"/>
               </a:rPr>
-              <a:t> lease = </a:t>
+              <a:t> reservationId = _idGenerator.</a:t>
             </a:r>
             <a:r>
               <a:rPr sz="980" b="1">
                 <a:solidFill>
+                  <a:srgbClr val="7F3FBF"/>
+                </a:solidFill>
+                <a:latin typeface="Consolas"/>
+                <a:ea typeface="Consolas"/>
+                <a:cs typeface="Consolas"/>
+              </a:rPr>
+              <a:t>NewReservationId</a:t>
+            </a:r>
+            <a:r>
+              <a:rPr sz="980" b="0">
+                <a:solidFill>
+                  <a:srgbClr val="202632"/>
+                </a:solidFill>
+                <a:latin typeface="Consolas"/>
+                <a:ea typeface="Consolas"/>
+                <a:cs typeface="Consolas"/>
+              </a:rPr>
+              <a:t>();</a:t>
+            </a:r>
+            <a:br/>
+            <a:r>
+              <a:rPr sz="980">
+                <a:solidFill>
+                  <a:srgbClr val="7A8699"/>
+                </a:solidFill>
+                <a:latin typeface="Consolas"/>
+                <a:ea typeface="Consolas"/>
+                <a:cs typeface="Consolas"/>
+              </a:rPr>
+              <a:t>13  </a:t>
+            </a:r>
+            <a:r>
+              <a:rPr sz="980" b="1">
+                <a:solidFill>
                   <a:srgbClr val="0563C1"/>
                 </a:solidFill>
                 <a:latin typeface="Consolas"/>
                 <a:ea typeface="Consolas"/>
                 <a:cs typeface="Consolas"/>
               </a:rPr>
+              <a:t>var</a:t>
+            </a:r>
+            <a:r>
+              <a:rPr sz="980" b="0">
+                <a:solidFill>
+                  <a:srgbClr val="202632"/>
+                </a:solidFill>
+                <a:latin typeface="Consolas"/>
+                <a:ea typeface="Consolas"/>
+                <a:cs typeface="Consolas"/>
+              </a:rPr>
+              <a:t> inventoryResult = </a:t>
+            </a:r>
+            <a:r>
+              <a:rPr sz="980" b="1">
+                <a:solidFill>
+                  <a:srgbClr val="0563C1"/>
+                </a:solidFill>
+                <a:latin typeface="Consolas"/>
+                <a:ea typeface="Consolas"/>
+                <a:cs typeface="Consolas"/>
+              </a:rPr>
               <a:t>await</a:t>
             </a:r>
             <a:r>
@@ -6557,7 +7249,29 @@
                 <a:ea typeface="Consolas"/>
                 <a:cs typeface="Consolas"/>
               </a:rPr>
-              <a:t> _requestLock</a:t>
+              <a:t> _inventory.</a:t>
+            </a:r>
+            <a:r>
+              <a:rPr sz="980" b="1">
+                <a:solidFill>
+                  <a:srgbClr val="7F3FBF"/>
+                </a:solidFill>
+                <a:latin typeface="Consolas"/>
+                <a:ea typeface="Consolas"/>
+                <a:cs typeface="Consolas"/>
+              </a:rPr>
+              <a:t>ReserveAsync</a:t>
+            </a:r>
+            <a:r>
+              <a:rPr sz="980" b="0">
+                <a:solidFill>
+                  <a:srgbClr val="202632"/>
+                </a:solidFill>
+                <a:latin typeface="Consolas"/>
+                <a:ea typeface="Consolas"/>
+                <a:cs typeface="Consolas"/>
+              </a:rPr>
+              <a:t>(</a:t>
             </a:r>
             <a:br/>
             <a:r>
@@ -6569,7 +7283,7 @@
                 <a:ea typeface="Consolas"/>
                 <a:cs typeface="Consolas"/>
               </a:rPr>
-              <a:t> 4  </a:t>
+              <a:t>14  </a:t>
             </a:r>
             <a:r>
               <a:rPr sz="980" b="0">
@@ -6580,18 +7294,40 @@
                 <a:ea typeface="Consolas"/>
                 <a:cs typeface="Consolas"/>
               </a:rPr>
-              <a:t>  .</a:t>
+              <a:t>  </a:t>
             </a:r>
             <a:r>
               <a:rPr sz="980" b="1">
                 <a:solidFill>
+                  <a:srgbClr val="0563C1"/>
+                </a:solidFill>
+                <a:latin typeface="Consolas"/>
+                <a:ea typeface="Consolas"/>
+                <a:cs typeface="Consolas"/>
+              </a:rPr>
+              <a:t>new</a:t>
+            </a:r>
+            <a:r>
+              <a:rPr sz="980" b="0">
+                <a:solidFill>
+                  <a:srgbClr val="202632"/>
+                </a:solidFill>
+                <a:latin typeface="Consolas"/>
+                <a:ea typeface="Consolas"/>
+                <a:cs typeface="Consolas"/>
+              </a:rPr>
+              <a:t>(command.</a:t>
+            </a:r>
+            <a:r>
+              <a:rPr sz="980" b="1">
+                <a:solidFill>
                   <a:srgbClr val="7F3FBF"/>
                 </a:solidFill>
                 <a:latin typeface="Consolas"/>
                 <a:ea typeface="Consolas"/>
                 <a:cs typeface="Consolas"/>
               </a:rPr>
-              <a:t>AcquireAsync</a:t>
+              <a:t>EquipmentId</a:t>
             </a:r>
             <a:r>
               <a:rPr sz="980" b="0">
@@ -6602,7 +7338,7 @@
                 <a:ea typeface="Consolas"/>
                 <a:cs typeface="Consolas"/>
               </a:rPr>
-              <a:t>(command.</a:t>
+              <a:t>, command.</a:t>
             </a:r>
             <a:r>
               <a:rPr sz="980" b="1">
@@ -6613,6 +7349,140 @@
                 <a:ea typeface="Consolas"/>
                 <a:cs typeface="Consolas"/>
               </a:rPr>
+              <a:t>Quantity</a:t>
+            </a:r>
+            <a:r>
+              <a:rPr sz="980" b="0">
+                <a:solidFill>
+                  <a:srgbClr val="202632"/>
+                </a:solidFill>
+                <a:latin typeface="Consolas"/>
+                <a:ea typeface="Consolas"/>
+                <a:cs typeface="Consolas"/>
+              </a:rPr>
+              <a:t>, reservationId), ct);</a:t>
+            </a:r>
+            <a:br/>
+            <a:r>
+              <a:rPr sz="980">
+                <a:solidFill>
+                  <a:srgbClr val="7A8699"/>
+                </a:solidFill>
+                <a:latin typeface="Consolas"/>
+                <a:ea typeface="Consolas"/>
+                <a:cs typeface="Consolas"/>
+              </a:rPr>
+              <a:t>15  </a:t>
+            </a:r>
+            <a:r>
+              <a:rPr sz="980" b="1">
+                <a:solidFill>
+                  <a:srgbClr val="0563C1"/>
+                </a:solidFill>
+                <a:latin typeface="Consolas"/>
+                <a:ea typeface="Consolas"/>
+                <a:cs typeface="Consolas"/>
+              </a:rPr>
+              <a:t>var</a:t>
+            </a:r>
+            <a:r>
+              <a:rPr sz="980" b="0">
+                <a:solidFill>
+                  <a:srgbClr val="202632"/>
+                </a:solidFill>
+                <a:latin typeface="Consolas"/>
+                <a:ea typeface="Consolas"/>
+                <a:cs typeface="Consolas"/>
+              </a:rPr>
+              <a:t> reservation = inventoryResult.</a:t>
+            </a:r>
+            <a:r>
+              <a:rPr sz="980" b="1">
+                <a:solidFill>
+                  <a:srgbClr val="7F3FBF"/>
+                </a:solidFill>
+                <a:latin typeface="Consolas"/>
+                <a:ea typeface="Consolas"/>
+                <a:cs typeface="Consolas"/>
+              </a:rPr>
+              <a:t>Success</a:t>
+            </a:r>
+            <a:br/>
+            <a:r>
+              <a:rPr sz="980">
+                <a:solidFill>
+                  <a:srgbClr val="7A8699"/>
+                </a:solidFill>
+                <a:latin typeface="Consolas"/>
+                <a:ea typeface="Consolas"/>
+                <a:cs typeface="Consolas"/>
+              </a:rPr>
+              <a:t>16  </a:t>
+            </a:r>
+            <a:r>
+              <a:rPr sz="980" b="0">
+                <a:solidFill>
+                  <a:srgbClr val="202632"/>
+                </a:solidFill>
+                <a:latin typeface="Consolas"/>
+                <a:ea typeface="Consolas"/>
+                <a:cs typeface="Consolas"/>
+              </a:rPr>
+              <a:t>  ? </a:t>
+            </a:r>
+            <a:r>
+              <a:rPr sz="980" b="1">
+                <a:solidFill>
+                  <a:srgbClr val="7F3FBF"/>
+                </a:solidFill>
+                <a:latin typeface="Consolas"/>
+                <a:ea typeface="Consolas"/>
+                <a:cs typeface="Consolas"/>
+              </a:rPr>
+              <a:t>Reservation</a:t>
+            </a:r>
+            <a:r>
+              <a:rPr sz="980" b="0">
+                <a:solidFill>
+                  <a:srgbClr val="202632"/>
+                </a:solidFill>
+                <a:latin typeface="Consolas"/>
+                <a:ea typeface="Consolas"/>
+                <a:cs typeface="Consolas"/>
+              </a:rPr>
+              <a:t>.</a:t>
+            </a:r>
+            <a:r>
+              <a:rPr sz="980" b="1">
+                <a:solidFill>
+                  <a:srgbClr val="7F3FBF"/>
+                </a:solidFill>
+                <a:latin typeface="Consolas"/>
+                <a:ea typeface="Consolas"/>
+                <a:cs typeface="Consolas"/>
+              </a:rPr>
+              <a:t>Confirmed</a:t>
+            </a:r>
+            <a:r>
+              <a:rPr sz="980" b="0">
+                <a:solidFill>
+                  <a:srgbClr val="202632"/>
+                </a:solidFill>
+                <a:latin typeface="Consolas"/>
+                <a:ea typeface="Consolas"/>
+                <a:cs typeface="Consolas"/>
+              </a:rPr>
+              <a:t>(reservationId, command.</a:t>
+            </a:r>
+            <a:r>
+              <a:rPr sz="980" b="1">
+                <a:solidFill>
+                  <a:srgbClr val="7F3FBF"/>
+                </a:solidFill>
+                <a:latin typeface="Consolas"/>
+                <a:ea typeface="Consolas"/>
+                <a:cs typeface="Consolas"/>
+              </a:rPr>
               <a:t>RequestId</a:t>
             </a:r>
             <a:r>
@@ -6624,7 +7494,7 @@
                 <a:ea typeface="Consolas"/>
                 <a:cs typeface="Consolas"/>
               </a:rPr>
-              <a:t>, ct);</a:t>
+              <a:t>,</a:t>
             </a:r>
             <a:br/>
             <a:r>
@@ -6636,18 +7506,330 @@
                 <a:ea typeface="Consolas"/>
                 <a:cs typeface="Consolas"/>
               </a:rPr>
-              <a:t> 5  </a:t>
+              <a:t>17  </a:t>
+            </a:r>
+            <a:r>
+              <a:rPr sz="980" b="0">
+                <a:solidFill>
+                  <a:srgbClr val="202632"/>
+                </a:solidFill>
+                <a:latin typeface="Consolas"/>
+                <a:ea typeface="Consolas"/>
+                <a:cs typeface="Consolas"/>
+              </a:rPr>
+              <a:t>      command.</a:t>
             </a:r>
             <a:r>
               <a:rPr sz="980" b="1">
                 <a:solidFill>
+                  <a:srgbClr val="7F3FBF"/>
+                </a:solidFill>
+                <a:latin typeface="Consolas"/>
+                <a:ea typeface="Consolas"/>
+                <a:cs typeface="Consolas"/>
+              </a:rPr>
+              <a:t>EquipmentId</a:t>
+            </a:r>
+            <a:r>
+              <a:rPr sz="980" b="0">
+                <a:solidFill>
+                  <a:srgbClr val="202632"/>
+                </a:solidFill>
+                <a:latin typeface="Consolas"/>
+                <a:ea typeface="Consolas"/>
+                <a:cs typeface="Consolas"/>
+              </a:rPr>
+              <a:t>, command.</a:t>
+            </a:r>
+            <a:r>
+              <a:rPr sz="980" b="1">
+                <a:solidFill>
+                  <a:srgbClr val="7F3FBF"/>
+                </a:solidFill>
+                <a:latin typeface="Consolas"/>
+                <a:ea typeface="Consolas"/>
+                <a:cs typeface="Consolas"/>
+              </a:rPr>
+              <a:t>StudentId</a:t>
+            </a:r>
+            <a:r>
+              <a:rPr sz="980" b="0">
+                <a:solidFill>
+                  <a:srgbClr val="202632"/>
+                </a:solidFill>
+                <a:latin typeface="Consolas"/>
+                <a:ea typeface="Consolas"/>
+                <a:cs typeface="Consolas"/>
+              </a:rPr>
+              <a:t>, command.</a:t>
+            </a:r>
+            <a:r>
+              <a:rPr sz="980" b="1">
+                <a:solidFill>
+                  <a:srgbClr val="7F3FBF"/>
+                </a:solidFill>
+                <a:latin typeface="Consolas"/>
+                <a:ea typeface="Consolas"/>
+                <a:cs typeface="Consolas"/>
+              </a:rPr>
+              <a:t>Quantity</a:t>
+            </a:r>
+            <a:r>
+              <a:rPr sz="980" b="0">
+                <a:solidFill>
+                  <a:srgbClr val="202632"/>
+                </a:solidFill>
+                <a:latin typeface="Consolas"/>
+                <a:ea typeface="Consolas"/>
+                <a:cs typeface="Consolas"/>
+              </a:rPr>
+              <a:t>)</a:t>
+            </a:r>
+            <a:br/>
+            <a:r>
+              <a:rPr sz="980">
+                <a:solidFill>
+                  <a:srgbClr val="7A8699"/>
+                </a:solidFill>
+                <a:latin typeface="Consolas"/>
+                <a:ea typeface="Consolas"/>
+                <a:cs typeface="Consolas"/>
+              </a:rPr>
+              <a:t>18  </a:t>
+            </a:r>
+            <a:r>
+              <a:rPr sz="980" b="0">
+                <a:solidFill>
+                  <a:srgbClr val="202632"/>
+                </a:solidFill>
+                <a:latin typeface="Consolas"/>
+                <a:ea typeface="Consolas"/>
+                <a:cs typeface="Consolas"/>
+              </a:rPr>
+              <a:t>  : </a:t>
+            </a:r>
+            <a:r>
+              <a:rPr sz="980" b="1">
+                <a:solidFill>
+                  <a:srgbClr val="7F3FBF"/>
+                </a:solidFill>
+                <a:latin typeface="Consolas"/>
+                <a:ea typeface="Consolas"/>
+                <a:cs typeface="Consolas"/>
+              </a:rPr>
+              <a:t>Reservation</a:t>
+            </a:r>
+            <a:r>
+              <a:rPr sz="980" b="0">
+                <a:solidFill>
+                  <a:srgbClr val="202632"/>
+                </a:solidFill>
+                <a:latin typeface="Consolas"/>
+                <a:ea typeface="Consolas"/>
+                <a:cs typeface="Consolas"/>
+              </a:rPr>
+              <a:t>.</a:t>
+            </a:r>
+            <a:r>
+              <a:rPr sz="980" b="1">
+                <a:solidFill>
+                  <a:srgbClr val="7F3FBF"/>
+                </a:solidFill>
+                <a:latin typeface="Consolas"/>
+                <a:ea typeface="Consolas"/>
+                <a:cs typeface="Consolas"/>
+              </a:rPr>
+              <a:t>Rejected</a:t>
+            </a:r>
+            <a:r>
+              <a:rPr sz="980" b="0">
+                <a:solidFill>
+                  <a:srgbClr val="202632"/>
+                </a:solidFill>
+                <a:latin typeface="Consolas"/>
+                <a:ea typeface="Consolas"/>
+                <a:cs typeface="Consolas"/>
+              </a:rPr>
+              <a:t>(reservationId, command.</a:t>
+            </a:r>
+            <a:r>
+              <a:rPr sz="980" b="1">
+                <a:solidFill>
+                  <a:srgbClr val="7F3FBF"/>
+                </a:solidFill>
+                <a:latin typeface="Consolas"/>
+                <a:ea typeface="Consolas"/>
+                <a:cs typeface="Consolas"/>
+              </a:rPr>
+              <a:t>RequestId</a:t>
+            </a:r>
+            <a:r>
+              <a:rPr sz="980" b="0">
+                <a:solidFill>
+                  <a:srgbClr val="202632"/>
+                </a:solidFill>
+                <a:latin typeface="Consolas"/>
+                <a:ea typeface="Consolas"/>
+                <a:cs typeface="Consolas"/>
+              </a:rPr>
+              <a:t>,</a:t>
+            </a:r>
+            <a:br/>
+            <a:r>
+              <a:rPr sz="980">
+                <a:solidFill>
+                  <a:srgbClr val="7A8699"/>
+                </a:solidFill>
+                <a:latin typeface="Consolas"/>
+                <a:ea typeface="Consolas"/>
+                <a:cs typeface="Consolas"/>
+              </a:rPr>
+              <a:t>19  </a:t>
+            </a:r>
+            <a:r>
+              <a:rPr sz="980" b="0">
+                <a:solidFill>
+                  <a:srgbClr val="202632"/>
+                </a:solidFill>
+                <a:latin typeface="Consolas"/>
+                <a:ea typeface="Consolas"/>
+                <a:cs typeface="Consolas"/>
+              </a:rPr>
+              <a:t>      command.</a:t>
+            </a:r>
+            <a:r>
+              <a:rPr sz="980" b="1">
+                <a:solidFill>
+                  <a:srgbClr val="7F3FBF"/>
+                </a:solidFill>
+                <a:latin typeface="Consolas"/>
+                <a:ea typeface="Consolas"/>
+                <a:cs typeface="Consolas"/>
+              </a:rPr>
+              <a:t>EquipmentId</a:t>
+            </a:r>
+            <a:r>
+              <a:rPr sz="980" b="0">
+                <a:solidFill>
+                  <a:srgbClr val="202632"/>
+                </a:solidFill>
+                <a:latin typeface="Consolas"/>
+                <a:ea typeface="Consolas"/>
+                <a:cs typeface="Consolas"/>
+              </a:rPr>
+              <a:t>, command.</a:t>
+            </a:r>
+            <a:r>
+              <a:rPr sz="980" b="1">
+                <a:solidFill>
+                  <a:srgbClr val="7F3FBF"/>
+                </a:solidFill>
+                <a:latin typeface="Consolas"/>
+                <a:ea typeface="Consolas"/>
+                <a:cs typeface="Consolas"/>
+              </a:rPr>
+              <a:t>StudentId</a:t>
+            </a:r>
+            <a:r>
+              <a:rPr sz="980" b="0">
+                <a:solidFill>
+                  <a:srgbClr val="202632"/>
+                </a:solidFill>
+                <a:latin typeface="Consolas"/>
+                <a:ea typeface="Consolas"/>
+                <a:cs typeface="Consolas"/>
+              </a:rPr>
+              <a:t>, command.</a:t>
+            </a:r>
+            <a:r>
+              <a:rPr sz="980" b="1">
+                <a:solidFill>
+                  <a:srgbClr val="7F3FBF"/>
+                </a:solidFill>
+                <a:latin typeface="Consolas"/>
+                <a:ea typeface="Consolas"/>
+                <a:cs typeface="Consolas"/>
+              </a:rPr>
+              <a:t>Quantity</a:t>
+            </a:r>
+            <a:r>
+              <a:rPr sz="980" b="0">
+                <a:solidFill>
+                  <a:srgbClr val="202632"/>
+                </a:solidFill>
+                <a:latin typeface="Consolas"/>
+                <a:ea typeface="Consolas"/>
+                <a:cs typeface="Consolas"/>
+              </a:rPr>
+              <a:t>,</a:t>
+            </a:r>
+            <a:br/>
+            <a:r>
+              <a:rPr sz="980">
+                <a:solidFill>
+                  <a:srgbClr val="7A8699"/>
+                </a:solidFill>
+                <a:latin typeface="Consolas"/>
+                <a:ea typeface="Consolas"/>
+                <a:cs typeface="Consolas"/>
+              </a:rPr>
+              <a:t>20  </a:t>
+            </a:r>
+            <a:r>
+              <a:rPr sz="980" b="0">
+                <a:solidFill>
+                  <a:srgbClr val="202632"/>
+                </a:solidFill>
+                <a:latin typeface="Consolas"/>
+                <a:ea typeface="Consolas"/>
+                <a:cs typeface="Consolas"/>
+              </a:rPr>
+              <a:t>      inventoryResult.</a:t>
+            </a:r>
+            <a:r>
+              <a:rPr sz="980" b="1">
+                <a:solidFill>
+                  <a:srgbClr val="7F3FBF"/>
+                </a:solidFill>
+                <a:latin typeface="Consolas"/>
+                <a:ea typeface="Consolas"/>
+                <a:cs typeface="Consolas"/>
+              </a:rPr>
+              <a:t>Error</a:t>
+            </a:r>
+            <a:r>
+              <a:rPr sz="980" b="0">
+                <a:solidFill>
+                  <a:srgbClr val="202632"/>
+                </a:solidFill>
+                <a:latin typeface="Consolas"/>
+                <a:ea typeface="Consolas"/>
+                <a:cs typeface="Consolas"/>
+              </a:rPr>
+              <a:t>);</a:t>
+            </a:r>
+            <a:br/>
+            <a:r>
+              <a:rPr sz="980">
+                <a:solidFill>
+                  <a:srgbClr val="7A8699"/>
+                </a:solidFill>
+                <a:latin typeface="Consolas"/>
+                <a:ea typeface="Consolas"/>
+                <a:cs typeface="Consolas"/>
+              </a:rPr>
+              <a:t>21  </a:t>
+            </a:r>
+            <a:r>
+              <a:rPr sz="980" b="1">
+                <a:solidFill>
                   <a:srgbClr val="0563C1"/>
                 </a:solidFill>
                 <a:latin typeface="Consolas"/>
                 <a:ea typeface="Consolas"/>
                 <a:cs typeface="Consolas"/>
               </a:rPr>
-              <a:t>var</a:t>
+              <a:t>await</a:t>
             </a:r>
             <a:r>
               <a:rPr sz="980" b="0">
@@ -6658,18 +7840,52 @@
                 <a:ea typeface="Consolas"/>
                 <a:cs typeface="Consolas"/>
               </a:rPr>
-              <a:t> existing = </a:t>
+              <a:t> _reservations.</a:t>
             </a:r>
             <a:r>
               <a:rPr sz="980" b="1">
                 <a:solidFill>
+                  <a:srgbClr val="7F3FBF"/>
+                </a:solidFill>
+                <a:latin typeface="Consolas"/>
+                <a:ea typeface="Consolas"/>
+                <a:cs typeface="Consolas"/>
+              </a:rPr>
+              <a:t>AddAsync</a:t>
+            </a:r>
+            <a:r>
+              <a:rPr sz="980" b="0">
+                <a:solidFill>
+                  <a:srgbClr val="202632"/>
+                </a:solidFill>
+                <a:latin typeface="Consolas"/>
+                <a:ea typeface="Consolas"/>
+                <a:cs typeface="Consolas"/>
+              </a:rPr>
+              <a:t>(reservation, ct);</a:t>
+            </a:r>
+            <a:br/>
+            <a:r>
+              <a:rPr sz="980">
+                <a:solidFill>
+                  <a:srgbClr val="7A8699"/>
+                </a:solidFill>
+                <a:latin typeface="Consolas"/>
+                <a:ea typeface="Consolas"/>
+                <a:cs typeface="Consolas"/>
+              </a:rPr>
+              <a:t>22  </a:t>
+            </a:r>
+            <a:r>
+              <a:rPr sz="980" b="1">
+                <a:solidFill>
                   <a:srgbClr val="0563C1"/>
                 </a:solidFill>
                 <a:latin typeface="Consolas"/>
                 <a:ea typeface="Consolas"/>
                 <a:cs typeface="Consolas"/>
               </a:rPr>
-              <a:t>await</a:t>
+              <a:t>return</a:t>
             </a:r>
             <a:r>
               <a:rPr sz="980" b="0">
@@ -6680,19 +7896,18 @@
                 <a:ea typeface="Consolas"/>
                 <a:cs typeface="Consolas"/>
               </a:rPr>
-              <a:t> _reservations</a:t>
-            </a:r>
-            <a:br/>
-            <a:r>
-              <a:rPr sz="980">
-                <a:solidFill>
-                  <a:srgbClr val="7A8699"/>
-                </a:solidFill>
-                <a:latin typeface="Consolas"/>
-                <a:ea typeface="Consolas"/>
-                <a:cs typeface="Consolas"/>
-              </a:rPr>
-              <a:t> 6  </a:t>
+              <a:t> </a:t>
+            </a:r>
+            <a:r>
+              <a:rPr sz="980" b="1">
+                <a:solidFill>
+                  <a:srgbClr val="7F3FBF"/>
+                </a:solidFill>
+                <a:latin typeface="Consolas"/>
+                <a:ea typeface="Consolas"/>
+                <a:cs typeface="Consolas"/>
+              </a:rPr>
+              <a:t>CreateReservationResult</a:t>
             </a:r>
             <a:r>
               <a:rPr sz="980" b="0">
@@ -6703,7 +7918,7 @@
                 <a:ea typeface="Consolas"/>
                 <a:cs typeface="Consolas"/>
               </a:rPr>
-              <a:t>  .</a:t>
+              <a:t>.</a:t>
             </a:r>
             <a:r>
               <a:rPr sz="980" b="1">
@@ -6714,968 +7929,7 @@
                 <a:ea typeface="Consolas"/>
                 <a:cs typeface="Consolas"/>
               </a:rPr>
-              <a:t>FindByRequestIdAsync</a:t>
-            </a:r>
-            <a:r>
-              <a:rPr sz="980" b="0">
-                <a:solidFill>
-                  <a:srgbClr val="202632"/>
-                </a:solidFill>
-                <a:latin typeface="Consolas"/>
-                <a:ea typeface="Consolas"/>
-                <a:cs typeface="Consolas"/>
-              </a:rPr>
-              <a:t>(command.</a:t>
-            </a:r>
-            <a:r>
-              <a:rPr sz="980" b="1">
-                <a:solidFill>
-                  <a:srgbClr val="7F3FBF"/>
-                </a:solidFill>
-                <a:latin typeface="Consolas"/>
-                <a:ea typeface="Consolas"/>
-                <a:cs typeface="Consolas"/>
-              </a:rPr>
-              <a:t>RequestId</a:t>
-            </a:r>
-            <a:r>
-              <a:rPr sz="980" b="0">
-                <a:solidFill>
-                  <a:srgbClr val="202632"/>
-                </a:solidFill>
-                <a:latin typeface="Consolas"/>
-                <a:ea typeface="Consolas"/>
-                <a:cs typeface="Consolas"/>
-              </a:rPr>
-              <a:t>, ct);</a:t>
-            </a:r>
-            <a:br/>
-            <a:r>
-              <a:rPr sz="980">
-                <a:solidFill>
-                  <a:srgbClr val="7A8699"/>
-                </a:solidFill>
-                <a:latin typeface="Consolas"/>
-                <a:ea typeface="Consolas"/>
-                <a:cs typeface="Consolas"/>
-              </a:rPr>
-              <a:t> 7  </a:t>
-            </a:r>
-            <a:r>
-              <a:rPr sz="980" b="1">
-                <a:solidFill>
-                  <a:srgbClr val="0563C1"/>
-                </a:solidFill>
-                <a:latin typeface="Consolas"/>
-                <a:ea typeface="Consolas"/>
-                <a:cs typeface="Consolas"/>
-              </a:rPr>
-              <a:t>if</a:t>
-            </a:r>
-            <a:r>
-              <a:rPr sz="980" b="0">
-                <a:solidFill>
-                  <a:srgbClr val="202632"/>
-                </a:solidFill>
-                <a:latin typeface="Consolas"/>
-                <a:ea typeface="Consolas"/>
-                <a:cs typeface="Consolas"/>
-              </a:rPr>
-              <a:t> (existing </a:t>
-            </a:r>
-            <a:r>
-              <a:rPr sz="980" b="1">
-                <a:solidFill>
-                  <a:srgbClr val="0563C1"/>
-                </a:solidFill>
-                <a:latin typeface="Consolas"/>
-                <a:ea typeface="Consolas"/>
-                <a:cs typeface="Consolas"/>
-              </a:rPr>
-              <a:t>is</a:t>
-            </a:r>
-            <a:r>
-              <a:rPr sz="980" b="0">
-                <a:solidFill>
-                  <a:srgbClr val="202632"/>
-                </a:solidFill>
-                <a:latin typeface="Consolas"/>
-                <a:ea typeface="Consolas"/>
-                <a:cs typeface="Consolas"/>
-              </a:rPr>
-              <a:t> </a:t>
-            </a:r>
-            <a:r>
-              <a:rPr sz="980" b="1">
-                <a:solidFill>
-                  <a:srgbClr val="0563C1"/>
-                </a:solidFill>
-                <a:latin typeface="Consolas"/>
-                <a:ea typeface="Consolas"/>
-                <a:cs typeface="Consolas"/>
-              </a:rPr>
-              <a:t>not</a:t>
-            </a:r>
-            <a:r>
-              <a:rPr sz="980" b="0">
-                <a:solidFill>
-                  <a:srgbClr val="202632"/>
-                </a:solidFill>
-                <a:latin typeface="Consolas"/>
-                <a:ea typeface="Consolas"/>
-                <a:cs typeface="Consolas"/>
-              </a:rPr>
-              <a:t> </a:t>
-            </a:r>
-            <a:r>
-              <a:rPr sz="980" b="1">
-                <a:solidFill>
-                  <a:srgbClr val="0563C1"/>
-                </a:solidFill>
-                <a:latin typeface="Consolas"/>
-                <a:ea typeface="Consolas"/>
-                <a:cs typeface="Consolas"/>
-              </a:rPr>
-              <a:t>null</a:t>
-            </a:r>
-            <a:r>
-              <a:rPr sz="980" b="0">
-                <a:solidFill>
-                  <a:srgbClr val="202632"/>
-                </a:solidFill>
-                <a:latin typeface="Consolas"/>
-                <a:ea typeface="Consolas"/>
-                <a:cs typeface="Consolas"/>
-              </a:rPr>
-              <a:t>)</a:t>
-            </a:r>
-            <a:br/>
-            <a:r>
-              <a:rPr sz="980">
-                <a:solidFill>
-                  <a:srgbClr val="7A8699"/>
-                </a:solidFill>
-                <a:latin typeface="Consolas"/>
-                <a:ea typeface="Consolas"/>
-                <a:cs typeface="Consolas"/>
-              </a:rPr>
-              <a:t> 8  </a:t>
-            </a:r>
-            <a:r>
-              <a:rPr sz="980" b="0">
-                <a:solidFill>
-                  <a:srgbClr val="202632"/>
-                </a:solidFill>
-                <a:latin typeface="Consolas"/>
-                <a:ea typeface="Consolas"/>
-                <a:cs typeface="Consolas"/>
-              </a:rPr>
-              <a:t>  </a:t>
-            </a:r>
-            <a:r>
-              <a:rPr sz="980" b="1">
-                <a:solidFill>
-                  <a:srgbClr val="0563C1"/>
-                </a:solidFill>
-                <a:latin typeface="Consolas"/>
-                <a:ea typeface="Consolas"/>
-                <a:cs typeface="Consolas"/>
-              </a:rPr>
-              <a:t>return</a:t>
-            </a:r>
-            <a:r>
-              <a:rPr sz="980" b="0">
-                <a:solidFill>
-                  <a:srgbClr val="202632"/>
-                </a:solidFill>
-                <a:latin typeface="Consolas"/>
-                <a:ea typeface="Consolas"/>
-                <a:cs typeface="Consolas"/>
-              </a:rPr>
-              <a:t> </a:t>
-            </a:r>
-            <a:r>
-              <a:rPr sz="980" b="1">
-                <a:solidFill>
-                  <a:srgbClr val="7F3FBF"/>
-                </a:solidFill>
-                <a:latin typeface="Consolas"/>
-                <a:ea typeface="Consolas"/>
-                <a:cs typeface="Consolas"/>
-              </a:rPr>
-              <a:t>Map</a:t>
-            </a:r>
-            <a:r>
-              <a:rPr sz="980" b="0">
-                <a:solidFill>
-                  <a:srgbClr val="202632"/>
-                </a:solidFill>
-                <a:latin typeface="Consolas"/>
-                <a:ea typeface="Consolas"/>
-                <a:cs typeface="Consolas"/>
-              </a:rPr>
-              <a:t>(existing, replayed: </a:t>
-            </a:r>
-            <a:r>
-              <a:rPr sz="980" b="1">
-                <a:solidFill>
-                  <a:srgbClr val="0563C1"/>
-                </a:solidFill>
-                <a:latin typeface="Consolas"/>
-                <a:ea typeface="Consolas"/>
-                <a:cs typeface="Consolas"/>
-              </a:rPr>
-              <a:t>true</a:t>
-            </a:r>
-            <a:r>
-              <a:rPr sz="980" b="0">
-                <a:solidFill>
-                  <a:srgbClr val="202632"/>
-                </a:solidFill>
-                <a:latin typeface="Consolas"/>
-                <a:ea typeface="Consolas"/>
-                <a:cs typeface="Consolas"/>
-              </a:rPr>
-              <a:t>);</a:t>
-            </a:r>
-            <a:br/>
-            <a:r>
-              <a:rPr sz="980">
-                <a:solidFill>
-                  <a:srgbClr val="7A8699"/>
-                </a:solidFill>
-                <a:latin typeface="Consolas"/>
-                <a:ea typeface="Consolas"/>
-                <a:cs typeface="Consolas"/>
-              </a:rPr>
-              <a:t> 9  </a:t>
-            </a:r>
-            <a:r>
-              <a:rPr sz="980" b="1">
-                <a:solidFill>
-                  <a:srgbClr val="0563C1"/>
-                </a:solidFill>
-                <a:latin typeface="Consolas"/>
-                <a:ea typeface="Consolas"/>
-                <a:cs typeface="Consolas"/>
-              </a:rPr>
-              <a:t>var</a:t>
-            </a:r>
-            <a:r>
-              <a:rPr sz="980" b="0">
-                <a:solidFill>
-                  <a:srgbClr val="202632"/>
-                </a:solidFill>
-                <a:latin typeface="Consolas"/>
-                <a:ea typeface="Consolas"/>
-                <a:cs typeface="Consolas"/>
-              </a:rPr>
-              <a:t> inventoryResult = </a:t>
-            </a:r>
-            <a:r>
-              <a:rPr sz="980" b="1">
-                <a:solidFill>
-                  <a:srgbClr val="0563C1"/>
-                </a:solidFill>
-                <a:latin typeface="Consolas"/>
-                <a:ea typeface="Consolas"/>
-                <a:cs typeface="Consolas"/>
-              </a:rPr>
-              <a:t>await</a:t>
-            </a:r>
-            <a:r>
-              <a:rPr sz="980" b="0">
-                <a:solidFill>
-                  <a:srgbClr val="202632"/>
-                </a:solidFill>
-                <a:latin typeface="Consolas"/>
-                <a:ea typeface="Consolas"/>
-                <a:cs typeface="Consolas"/>
-              </a:rPr>
-              <a:t> _inventory.</a:t>
-            </a:r>
-            <a:r>
-              <a:rPr sz="980" b="1">
-                <a:solidFill>
-                  <a:srgbClr val="7F3FBF"/>
-                </a:solidFill>
-                <a:latin typeface="Consolas"/>
-                <a:ea typeface="Consolas"/>
-                <a:cs typeface="Consolas"/>
-              </a:rPr>
-              <a:t>ReserveAsync</a:t>
-            </a:r>
-            <a:r>
-              <a:rPr sz="980" b="0">
-                <a:solidFill>
-                  <a:srgbClr val="202632"/>
-                </a:solidFill>
-                <a:latin typeface="Consolas"/>
-                <a:ea typeface="Consolas"/>
-                <a:cs typeface="Consolas"/>
-              </a:rPr>
-              <a:t>(</a:t>
-            </a:r>
-            <a:br/>
-            <a:r>
-              <a:rPr sz="980">
-                <a:solidFill>
-                  <a:srgbClr val="7A8699"/>
-                </a:solidFill>
-                <a:latin typeface="Consolas"/>
-                <a:ea typeface="Consolas"/>
-                <a:cs typeface="Consolas"/>
-              </a:rPr>
-              <a:t>10  </a:t>
-            </a:r>
-            <a:r>
-              <a:rPr sz="980" b="0">
-                <a:solidFill>
-                  <a:srgbClr val="202632"/>
-                </a:solidFill>
-                <a:latin typeface="Consolas"/>
-                <a:ea typeface="Consolas"/>
-                <a:cs typeface="Consolas"/>
-              </a:rPr>
-              <a:t>  </a:t>
-            </a:r>
-            <a:r>
-              <a:rPr sz="980" b="1">
-                <a:solidFill>
-                  <a:srgbClr val="0563C1"/>
-                </a:solidFill>
-                <a:latin typeface="Consolas"/>
-                <a:ea typeface="Consolas"/>
-                <a:cs typeface="Consolas"/>
-              </a:rPr>
-              <a:t>new</a:t>
-            </a:r>
-            <a:r>
-              <a:rPr sz="980" b="0">
-                <a:solidFill>
-                  <a:srgbClr val="202632"/>
-                </a:solidFill>
-                <a:latin typeface="Consolas"/>
-                <a:ea typeface="Consolas"/>
-                <a:cs typeface="Consolas"/>
-              </a:rPr>
-              <a:t>(command.</a:t>
-            </a:r>
-            <a:r>
-              <a:rPr sz="980" b="1">
-                <a:solidFill>
-                  <a:srgbClr val="7F3FBF"/>
-                </a:solidFill>
-                <a:latin typeface="Consolas"/>
-                <a:ea typeface="Consolas"/>
-                <a:cs typeface="Consolas"/>
-              </a:rPr>
-              <a:t>EquipmentId</a:t>
-            </a:r>
-            <a:r>
-              <a:rPr sz="980" b="0">
-                <a:solidFill>
-                  <a:srgbClr val="202632"/>
-                </a:solidFill>
-                <a:latin typeface="Consolas"/>
-                <a:ea typeface="Consolas"/>
-                <a:cs typeface="Consolas"/>
-              </a:rPr>
-              <a:t>, command.</a:t>
-            </a:r>
-            <a:r>
-              <a:rPr sz="980" b="1">
-                <a:solidFill>
-                  <a:srgbClr val="7F3FBF"/>
-                </a:solidFill>
-                <a:latin typeface="Consolas"/>
-                <a:ea typeface="Consolas"/>
-                <a:cs typeface="Consolas"/>
-              </a:rPr>
-              <a:t>Quantity</a:t>
-            </a:r>
-            <a:r>
-              <a:rPr sz="980" b="0">
-                <a:solidFill>
-                  <a:srgbClr val="202632"/>
-                </a:solidFill>
-                <a:latin typeface="Consolas"/>
-                <a:ea typeface="Consolas"/>
-                <a:cs typeface="Consolas"/>
-              </a:rPr>
-              <a:t>,</a:t>
-            </a:r>
-            <a:br/>
-            <a:r>
-              <a:rPr sz="980">
-                <a:solidFill>
-                  <a:srgbClr val="7A8699"/>
-                </a:solidFill>
-                <a:latin typeface="Consolas"/>
-                <a:ea typeface="Consolas"/>
-                <a:cs typeface="Consolas"/>
-              </a:rPr>
-              <a:t>11  </a:t>
-            </a:r>
-            <a:r>
-              <a:rPr sz="980" b="0">
-                <a:solidFill>
-                  <a:srgbClr val="202632"/>
-                </a:solidFill>
-                <a:latin typeface="Consolas"/>
-                <a:ea typeface="Consolas"/>
-                <a:cs typeface="Consolas"/>
-              </a:rPr>
-              <a:t>      reservationId), ct);</a:t>
-            </a:r>
-            <a:br/>
-            <a:r>
-              <a:rPr sz="980">
-                <a:solidFill>
-                  <a:srgbClr val="7A8699"/>
-                </a:solidFill>
-                <a:latin typeface="Consolas"/>
-                <a:ea typeface="Consolas"/>
-                <a:cs typeface="Consolas"/>
-              </a:rPr>
-              <a:t>12  </a:t>
-            </a:r>
-            <a:r>
-              <a:rPr sz="980" b="1">
-                <a:solidFill>
-                  <a:srgbClr val="0563C1"/>
-                </a:solidFill>
-                <a:latin typeface="Consolas"/>
-                <a:ea typeface="Consolas"/>
-                <a:cs typeface="Consolas"/>
-              </a:rPr>
-              <a:t>var</a:t>
-            </a:r>
-            <a:r>
-              <a:rPr sz="980" b="0">
-                <a:solidFill>
-                  <a:srgbClr val="202632"/>
-                </a:solidFill>
-                <a:latin typeface="Consolas"/>
-                <a:ea typeface="Consolas"/>
-                <a:cs typeface="Consolas"/>
-              </a:rPr>
-              <a:t> status = inventoryResult.</a:t>
-            </a:r>
-            <a:r>
-              <a:rPr sz="980" b="1">
-                <a:solidFill>
-                  <a:srgbClr val="7F3FBF"/>
-                </a:solidFill>
-                <a:latin typeface="Consolas"/>
-                <a:ea typeface="Consolas"/>
-                <a:cs typeface="Consolas"/>
-              </a:rPr>
-              <a:t>Success</a:t>
-            </a:r>
-            <a:br/>
-            <a:r>
-              <a:rPr sz="980">
-                <a:solidFill>
-                  <a:srgbClr val="7A8699"/>
-                </a:solidFill>
-                <a:latin typeface="Consolas"/>
-                <a:ea typeface="Consolas"/>
-                <a:cs typeface="Consolas"/>
-              </a:rPr>
-              <a:t>13  </a:t>
-            </a:r>
-            <a:r>
-              <a:rPr sz="980" b="0">
-                <a:solidFill>
-                  <a:srgbClr val="202632"/>
-                </a:solidFill>
-                <a:latin typeface="Consolas"/>
-                <a:ea typeface="Consolas"/>
-                <a:cs typeface="Consolas"/>
-              </a:rPr>
-              <a:t>  ? </a:t>
-            </a:r>
-            <a:r>
-              <a:rPr sz="980" b="1">
-                <a:solidFill>
-                  <a:srgbClr val="7F3FBF"/>
-                </a:solidFill>
-                <a:latin typeface="Consolas"/>
-                <a:ea typeface="Consolas"/>
-                <a:cs typeface="Consolas"/>
-              </a:rPr>
-              <a:t>ReservationStatus</a:t>
-            </a:r>
-            <a:r>
-              <a:rPr sz="980" b="0">
-                <a:solidFill>
-                  <a:srgbClr val="202632"/>
-                </a:solidFill>
-                <a:latin typeface="Consolas"/>
-                <a:ea typeface="Consolas"/>
-                <a:cs typeface="Consolas"/>
-              </a:rPr>
-              <a:t>.</a:t>
-            </a:r>
-            <a:r>
-              <a:rPr sz="980" b="1">
-                <a:solidFill>
-                  <a:srgbClr val="7F3FBF"/>
-                </a:solidFill>
-                <a:latin typeface="Consolas"/>
-                <a:ea typeface="Consolas"/>
-                <a:cs typeface="Consolas"/>
-              </a:rPr>
-              <a:t>Confirmed</a:t>
-            </a:r>
-            <a:br/>
-            <a:r>
-              <a:rPr sz="980">
-                <a:solidFill>
-                  <a:srgbClr val="7A8699"/>
-                </a:solidFill>
-                <a:latin typeface="Consolas"/>
-                <a:ea typeface="Consolas"/>
-                <a:cs typeface="Consolas"/>
-              </a:rPr>
-              <a:t>14  </a:t>
-            </a:r>
-            <a:r>
-              <a:rPr sz="980" b="0">
-                <a:solidFill>
-                  <a:srgbClr val="202632"/>
-                </a:solidFill>
-                <a:latin typeface="Consolas"/>
-                <a:ea typeface="Consolas"/>
-                <a:cs typeface="Consolas"/>
-              </a:rPr>
-              <a:t>  : </a:t>
-            </a:r>
-            <a:r>
-              <a:rPr sz="980" b="1">
-                <a:solidFill>
-                  <a:srgbClr val="7F3FBF"/>
-                </a:solidFill>
-                <a:latin typeface="Consolas"/>
-                <a:ea typeface="Consolas"/>
-                <a:cs typeface="Consolas"/>
-              </a:rPr>
-              <a:t>ReservationStatus</a:t>
-            </a:r>
-            <a:r>
-              <a:rPr sz="980" b="0">
-                <a:solidFill>
-                  <a:srgbClr val="202632"/>
-                </a:solidFill>
-                <a:latin typeface="Consolas"/>
-                <a:ea typeface="Consolas"/>
-                <a:cs typeface="Consolas"/>
-              </a:rPr>
-              <a:t>.</a:t>
-            </a:r>
-            <a:r>
-              <a:rPr sz="980" b="1">
-                <a:solidFill>
-                  <a:srgbClr val="7F3FBF"/>
-                </a:solidFill>
-                <a:latin typeface="Consolas"/>
-                <a:ea typeface="Consolas"/>
-                <a:cs typeface="Consolas"/>
-              </a:rPr>
-              <a:t>Rejected</a:t>
-            </a:r>
-            <a:r>
-              <a:rPr sz="980" b="0">
-                <a:solidFill>
-                  <a:srgbClr val="202632"/>
-                </a:solidFill>
-                <a:latin typeface="Consolas"/>
-                <a:ea typeface="Consolas"/>
-                <a:cs typeface="Consolas"/>
-              </a:rPr>
-              <a:t>;</a:t>
-            </a:r>
-            <a:br/>
-            <a:r>
-              <a:rPr sz="980">
-                <a:solidFill>
-                  <a:srgbClr val="7A8699"/>
-                </a:solidFill>
-                <a:latin typeface="Consolas"/>
-                <a:ea typeface="Consolas"/>
-                <a:cs typeface="Consolas"/>
-              </a:rPr>
-              <a:t>15  </a:t>
-            </a:r>
-            <a:r>
-              <a:rPr sz="980" b="1">
-                <a:solidFill>
-                  <a:srgbClr val="0563C1"/>
-                </a:solidFill>
-                <a:latin typeface="Consolas"/>
-                <a:ea typeface="Consolas"/>
-                <a:cs typeface="Consolas"/>
-              </a:rPr>
-              <a:t>var</a:t>
-            </a:r>
-            <a:r>
-              <a:rPr sz="980" b="0">
-                <a:solidFill>
-                  <a:srgbClr val="202632"/>
-                </a:solidFill>
-                <a:latin typeface="Consolas"/>
-                <a:ea typeface="Consolas"/>
-                <a:cs typeface="Consolas"/>
-              </a:rPr>
-              <a:t> reservation = </a:t>
-            </a:r>
-            <a:r>
-              <a:rPr sz="980" b="1">
-                <a:solidFill>
-                  <a:srgbClr val="0563C1"/>
-                </a:solidFill>
-                <a:latin typeface="Consolas"/>
-                <a:ea typeface="Consolas"/>
-                <a:cs typeface="Consolas"/>
-              </a:rPr>
-              <a:t>new</a:t>
-            </a:r>
-            <a:r>
-              <a:rPr sz="980" b="0">
-                <a:solidFill>
-                  <a:srgbClr val="202632"/>
-                </a:solidFill>
-                <a:latin typeface="Consolas"/>
-                <a:ea typeface="Consolas"/>
-                <a:cs typeface="Consolas"/>
-              </a:rPr>
-              <a:t> </a:t>
-            </a:r>
-            <a:r>
-              <a:rPr sz="980" b="1">
-                <a:solidFill>
-                  <a:srgbClr val="7F3FBF"/>
-                </a:solidFill>
-                <a:latin typeface="Consolas"/>
-                <a:ea typeface="Consolas"/>
-                <a:cs typeface="Consolas"/>
-              </a:rPr>
-              <a:t>Reservation</a:t>
-            </a:r>
-            <a:r>
-              <a:rPr sz="980" b="0">
-                <a:solidFill>
-                  <a:srgbClr val="202632"/>
-                </a:solidFill>
-                <a:latin typeface="Consolas"/>
-                <a:ea typeface="Consolas"/>
-                <a:cs typeface="Consolas"/>
-              </a:rPr>
-              <a:t>(</a:t>
-            </a:r>
-            <a:br/>
-            <a:r>
-              <a:rPr sz="980">
-                <a:solidFill>
-                  <a:srgbClr val="7A8699"/>
-                </a:solidFill>
-                <a:latin typeface="Consolas"/>
-                <a:ea typeface="Consolas"/>
-                <a:cs typeface="Consolas"/>
-              </a:rPr>
-              <a:t>16  </a:t>
-            </a:r>
-            <a:r>
-              <a:rPr sz="980" b="0">
-                <a:solidFill>
-                  <a:srgbClr val="202632"/>
-                </a:solidFill>
-                <a:latin typeface="Consolas"/>
-                <a:ea typeface="Consolas"/>
-                <a:cs typeface="Consolas"/>
-              </a:rPr>
-              <a:t>  reservationId, command.</a:t>
-            </a:r>
-            <a:r>
-              <a:rPr sz="980" b="1">
-                <a:solidFill>
-                  <a:srgbClr val="7F3FBF"/>
-                </a:solidFill>
-                <a:latin typeface="Consolas"/>
-                <a:ea typeface="Consolas"/>
-                <a:cs typeface="Consolas"/>
-              </a:rPr>
-              <a:t>RequestId</a:t>
-            </a:r>
-            <a:r>
-              <a:rPr sz="980" b="0">
-                <a:solidFill>
-                  <a:srgbClr val="202632"/>
-                </a:solidFill>
-                <a:latin typeface="Consolas"/>
-                <a:ea typeface="Consolas"/>
-                <a:cs typeface="Consolas"/>
-              </a:rPr>
-              <a:t>,</a:t>
-            </a:r>
-            <a:br/>
-            <a:r>
-              <a:rPr sz="980">
-                <a:solidFill>
-                  <a:srgbClr val="7A8699"/>
-                </a:solidFill>
-                <a:latin typeface="Consolas"/>
-                <a:ea typeface="Consolas"/>
-                <a:cs typeface="Consolas"/>
-              </a:rPr>
-              <a:t>17  </a:t>
-            </a:r>
-            <a:r>
-              <a:rPr sz="980" b="0">
-                <a:solidFill>
-                  <a:srgbClr val="202632"/>
-                </a:solidFill>
-                <a:latin typeface="Consolas"/>
-                <a:ea typeface="Consolas"/>
-                <a:cs typeface="Consolas"/>
-              </a:rPr>
-              <a:t>  command.</a:t>
-            </a:r>
-            <a:r>
-              <a:rPr sz="980" b="1">
-                <a:solidFill>
-                  <a:srgbClr val="7F3FBF"/>
-                </a:solidFill>
-                <a:latin typeface="Consolas"/>
-                <a:ea typeface="Consolas"/>
-                <a:cs typeface="Consolas"/>
-              </a:rPr>
-              <a:t>EquipmentId</a:t>
-            </a:r>
-            <a:r>
-              <a:rPr sz="980" b="0">
-                <a:solidFill>
-                  <a:srgbClr val="202632"/>
-                </a:solidFill>
-                <a:latin typeface="Consolas"/>
-                <a:ea typeface="Consolas"/>
-                <a:cs typeface="Consolas"/>
-              </a:rPr>
-              <a:t>, command.</a:t>
-            </a:r>
-            <a:r>
-              <a:rPr sz="980" b="1">
-                <a:solidFill>
-                  <a:srgbClr val="7F3FBF"/>
-                </a:solidFill>
-                <a:latin typeface="Consolas"/>
-                <a:ea typeface="Consolas"/>
-                <a:cs typeface="Consolas"/>
-              </a:rPr>
-              <a:t>StudentId</a:t>
-            </a:r>
-            <a:r>
-              <a:rPr sz="980" b="0">
-                <a:solidFill>
-                  <a:srgbClr val="202632"/>
-                </a:solidFill>
-                <a:latin typeface="Consolas"/>
-                <a:ea typeface="Consolas"/>
-                <a:cs typeface="Consolas"/>
-              </a:rPr>
-              <a:t>,</a:t>
-            </a:r>
-            <a:br/>
-            <a:r>
-              <a:rPr sz="980">
-                <a:solidFill>
-                  <a:srgbClr val="7A8699"/>
-                </a:solidFill>
-                <a:latin typeface="Consolas"/>
-                <a:ea typeface="Consolas"/>
-                <a:cs typeface="Consolas"/>
-              </a:rPr>
-              <a:t>18  </a:t>
-            </a:r>
-            <a:r>
-              <a:rPr sz="980" b="0">
-                <a:solidFill>
-                  <a:srgbClr val="202632"/>
-                </a:solidFill>
-                <a:latin typeface="Consolas"/>
-                <a:ea typeface="Consolas"/>
-                <a:cs typeface="Consolas"/>
-              </a:rPr>
-              <a:t>  command.</a:t>
-            </a:r>
-            <a:r>
-              <a:rPr sz="980" b="1">
-                <a:solidFill>
-                  <a:srgbClr val="7F3FBF"/>
-                </a:solidFill>
-                <a:latin typeface="Consolas"/>
-                <a:ea typeface="Consolas"/>
-                <a:cs typeface="Consolas"/>
-              </a:rPr>
-              <a:t>Quantity</a:t>
-            </a:r>
-            <a:r>
-              <a:rPr sz="980" b="0">
-                <a:solidFill>
-                  <a:srgbClr val="202632"/>
-                </a:solidFill>
-                <a:latin typeface="Consolas"/>
-                <a:ea typeface="Consolas"/>
-                <a:cs typeface="Consolas"/>
-              </a:rPr>
-              <a:t>, status,</a:t>
-            </a:r>
-            <a:br/>
-            <a:r>
-              <a:rPr sz="980">
-                <a:solidFill>
-                  <a:srgbClr val="7A8699"/>
-                </a:solidFill>
-                <a:latin typeface="Consolas"/>
-                <a:ea typeface="Consolas"/>
-                <a:cs typeface="Consolas"/>
-              </a:rPr>
-              <a:t>19  </a:t>
-            </a:r>
-            <a:r>
-              <a:rPr sz="980" b="0">
-                <a:solidFill>
-                  <a:srgbClr val="202632"/>
-                </a:solidFill>
-                <a:latin typeface="Consolas"/>
-                <a:ea typeface="Consolas"/>
-                <a:cs typeface="Consolas"/>
-              </a:rPr>
-              <a:t>  inventoryResult.</a:t>
-            </a:r>
-            <a:r>
-              <a:rPr sz="980" b="1">
-                <a:solidFill>
-                  <a:srgbClr val="7F3FBF"/>
-                </a:solidFill>
-                <a:latin typeface="Consolas"/>
-                <a:ea typeface="Consolas"/>
-                <a:cs typeface="Consolas"/>
-              </a:rPr>
-              <a:t>ErrorCode</a:t>
-            </a:r>
-            <a:r>
-              <a:rPr sz="980" b="0">
-                <a:solidFill>
-                  <a:srgbClr val="202632"/>
-                </a:solidFill>
-                <a:latin typeface="Consolas"/>
-                <a:ea typeface="Consolas"/>
-                <a:cs typeface="Consolas"/>
-              </a:rPr>
-              <a:t>);</a:t>
-            </a:r>
-            <a:br/>
-            <a:r>
-              <a:rPr sz="980">
-                <a:solidFill>
-                  <a:srgbClr val="7A8699"/>
-                </a:solidFill>
-                <a:latin typeface="Consolas"/>
-                <a:ea typeface="Consolas"/>
-                <a:cs typeface="Consolas"/>
-              </a:rPr>
-              <a:t>20  </a:t>
-            </a:r>
-            <a:r>
-              <a:rPr sz="980" b="1">
-                <a:solidFill>
-                  <a:srgbClr val="0563C1"/>
-                </a:solidFill>
-                <a:latin typeface="Consolas"/>
-                <a:ea typeface="Consolas"/>
-                <a:cs typeface="Consolas"/>
-              </a:rPr>
-              <a:t>await</a:t>
-            </a:r>
-            <a:r>
-              <a:rPr sz="980" b="0">
-                <a:solidFill>
-                  <a:srgbClr val="202632"/>
-                </a:solidFill>
-                <a:latin typeface="Consolas"/>
-                <a:ea typeface="Consolas"/>
-                <a:cs typeface="Consolas"/>
-              </a:rPr>
-              <a:t> _reservations.</a:t>
-            </a:r>
-            <a:r>
-              <a:rPr sz="980" b="1">
-                <a:solidFill>
-                  <a:srgbClr val="7F3FBF"/>
-                </a:solidFill>
-                <a:latin typeface="Consolas"/>
-                <a:ea typeface="Consolas"/>
-                <a:cs typeface="Consolas"/>
-              </a:rPr>
-              <a:t>AddAsync</a:t>
-            </a:r>
-            <a:r>
-              <a:rPr sz="980" b="0">
-                <a:solidFill>
-                  <a:srgbClr val="202632"/>
-                </a:solidFill>
-                <a:latin typeface="Consolas"/>
-                <a:ea typeface="Consolas"/>
-                <a:cs typeface="Consolas"/>
-              </a:rPr>
-              <a:t>(reservation, ct);</a:t>
-            </a:r>
-            <a:br/>
-            <a:r>
-              <a:rPr sz="980">
-                <a:solidFill>
-                  <a:srgbClr val="7A8699"/>
-                </a:solidFill>
-                <a:latin typeface="Consolas"/>
-                <a:ea typeface="Consolas"/>
-                <a:cs typeface="Consolas"/>
-              </a:rPr>
-              <a:t>21  </a:t>
-            </a:r>
-            <a:r>
-              <a:rPr sz="980" b="1">
-                <a:solidFill>
-                  <a:srgbClr val="0563C1"/>
-                </a:solidFill>
-                <a:latin typeface="Consolas"/>
-                <a:ea typeface="Consolas"/>
-                <a:cs typeface="Consolas"/>
-              </a:rPr>
-              <a:t>return</a:t>
-            </a:r>
-            <a:r>
-              <a:rPr sz="980" b="0">
-                <a:solidFill>
-                  <a:srgbClr val="202632"/>
-                </a:solidFill>
-                <a:latin typeface="Consolas"/>
-                <a:ea typeface="Consolas"/>
-                <a:cs typeface="Consolas"/>
-              </a:rPr>
-              <a:t> </a:t>
-            </a:r>
-            <a:r>
-              <a:rPr sz="980" b="1">
-                <a:solidFill>
-                  <a:srgbClr val="7F3FBF"/>
-                </a:solidFill>
-                <a:latin typeface="Consolas"/>
-                <a:ea typeface="Consolas"/>
-                <a:cs typeface="Consolas"/>
-              </a:rPr>
-              <a:t>Map</a:t>
+              <a:t>From</a:t>
             </a:r>
             <a:r>
               <a:rPr sz="980" b="0">
@@ -25597,13 +25851,192 @@
             <a:r>
               <a:rPr sz="1150" b="1">
                 <a:solidFill>
+                  <a:srgbClr val="7F3FBF"/>
+                </a:solidFill>
+                <a:latin typeface="Consolas"/>
+                <a:ea typeface="Consolas"/>
+                <a:cs typeface="Consolas"/>
+              </a:rPr>
+              <a:t>Result</a:t>
+            </a:r>
+            <a:r>
+              <a:rPr sz="1150" b="0">
+                <a:solidFill>
+                  <a:srgbClr val="202632"/>
+                </a:solidFill>
+                <a:latin typeface="Consolas"/>
+                <a:ea typeface="Consolas"/>
+                <a:cs typeface="Consolas"/>
+              </a:rPr>
+              <a:t> </a:t>
+            </a:r>
+            <a:r>
+              <a:rPr sz="1150" b="1">
+                <a:solidFill>
+                  <a:srgbClr val="7F3FBF"/>
+                </a:solidFill>
+                <a:latin typeface="Consolas"/>
+                <a:ea typeface="Consolas"/>
+                <a:cs typeface="Consolas"/>
+              </a:rPr>
+              <a:t>Validate</a:t>
+            </a:r>
+            <a:r>
+              <a:rPr sz="1150" b="0">
+                <a:solidFill>
+                  <a:srgbClr val="202632"/>
+                </a:solidFill>
+                <a:latin typeface="Consolas"/>
+                <a:ea typeface="Consolas"/>
+                <a:cs typeface="Consolas"/>
+              </a:rPr>
+              <a:t>(</a:t>
+            </a:r>
+            <a:r>
+              <a:rPr sz="1150" b="1">
+                <a:solidFill>
+                  <a:srgbClr val="7F3FBF"/>
+                </a:solidFill>
+                <a:latin typeface="Consolas"/>
+                <a:ea typeface="Consolas"/>
+                <a:cs typeface="Consolas"/>
+              </a:rPr>
+              <a:t>CreateReservationCommand</a:t>
+            </a:r>
+            <a:r>
+              <a:rPr sz="1150" b="0">
+                <a:solidFill>
+                  <a:srgbClr val="202632"/>
+                </a:solidFill>
+                <a:latin typeface="Consolas"/>
+                <a:ea typeface="Consolas"/>
+                <a:cs typeface="Consolas"/>
+              </a:rPr>
+              <a:t> command)</a:t>
+            </a:r>
+            <a:br/>
+            <a:r>
+              <a:rPr sz="1150">
+                <a:solidFill>
+                  <a:srgbClr val="7A8699"/>
+                </a:solidFill>
+                <a:latin typeface="Consolas"/>
+                <a:ea typeface="Consolas"/>
+                <a:cs typeface="Consolas"/>
+              </a:rPr>
+              <a:t> 2  </a:t>
+            </a:r>
+            <a:r>
+              <a:rPr sz="1150" b="0">
+                <a:solidFill>
+                  <a:srgbClr val="202632"/>
+                </a:solidFill>
+                <a:latin typeface="Consolas"/>
+                <a:ea typeface="Consolas"/>
+                <a:cs typeface="Consolas"/>
+              </a:rPr>
+              <a:t>{</a:t>
+            </a:r>
+            <a:br/>
+            <a:r>
+              <a:rPr sz="1150">
+                <a:solidFill>
+                  <a:srgbClr val="7A8699"/>
+                </a:solidFill>
+                <a:latin typeface="Consolas"/>
+                <a:ea typeface="Consolas"/>
+                <a:cs typeface="Consolas"/>
+              </a:rPr>
+              <a:t> 3  </a:t>
+            </a:r>
+            <a:r>
+              <a:rPr sz="1150" b="0">
+                <a:solidFill>
+                  <a:srgbClr val="202632"/>
+                </a:solidFill>
+                <a:latin typeface="Consolas"/>
+                <a:ea typeface="Consolas"/>
+                <a:cs typeface="Consolas"/>
+              </a:rPr>
+              <a:t>  </a:t>
+            </a:r>
+            <a:r>
+              <a:rPr sz="1150" b="1">
+                <a:solidFill>
+                  <a:srgbClr val="7F3FBF"/>
+                </a:solidFill>
+                <a:latin typeface="Consolas"/>
+                <a:ea typeface="Consolas"/>
+                <a:cs typeface="Consolas"/>
+              </a:rPr>
+              <a:t>ArgumentNullException</a:t>
+            </a:r>
+            <a:r>
+              <a:rPr sz="1150" b="0">
+                <a:solidFill>
+                  <a:srgbClr val="202632"/>
+                </a:solidFill>
+                <a:latin typeface="Consolas"/>
+                <a:ea typeface="Consolas"/>
+                <a:cs typeface="Consolas"/>
+              </a:rPr>
+              <a:t>.</a:t>
+            </a:r>
+            <a:r>
+              <a:rPr sz="1150" b="1">
+                <a:solidFill>
+                  <a:srgbClr val="7F3FBF"/>
+                </a:solidFill>
+                <a:latin typeface="Consolas"/>
+                <a:ea typeface="Consolas"/>
+                <a:cs typeface="Consolas"/>
+              </a:rPr>
+              <a:t>ThrowIfNull</a:t>
+            </a:r>
+            <a:r>
+              <a:rPr sz="1150" b="0">
+                <a:solidFill>
+                  <a:srgbClr val="202632"/>
+                </a:solidFill>
+                <a:latin typeface="Consolas"/>
+                <a:ea typeface="Consolas"/>
+                <a:cs typeface="Consolas"/>
+              </a:rPr>
+              <a:t>(command);</a:t>
+            </a:r>
+            <a:br/>
+            <a:r>
+              <a:rPr sz="1150">
+                <a:solidFill>
+                  <a:srgbClr val="7A8699"/>
+                </a:solidFill>
+                <a:latin typeface="Consolas"/>
+                <a:ea typeface="Consolas"/>
+                <a:cs typeface="Consolas"/>
+              </a:rPr>
+              <a:t> 4  </a:t>
+            </a:r>
+            <a:r>
+              <a:rPr sz="1150" b="0">
+                <a:solidFill>
+                  <a:srgbClr val="202632"/>
+                </a:solidFill>
+                <a:latin typeface="Consolas"/>
+                <a:ea typeface="Consolas"/>
+                <a:cs typeface="Consolas"/>
+              </a:rPr>
+              <a:t>  </a:t>
+            </a:r>
+            <a:r>
+              <a:rPr sz="1150" b="1">
+                <a:solidFill>
                   <a:srgbClr val="0563C1"/>
                 </a:solidFill>
                 <a:latin typeface="Consolas"/>
                 <a:ea typeface="Consolas"/>
                 <a:cs typeface="Consolas"/>
               </a:rPr>
-              <a:t>static</a:t>
+              <a:t>if</a:t>
             </a:r>
             <a:r>
               <a:rPr sz="1150" b="0">
@@ -25614,18 +26047,263 @@
                 <a:ea typeface="Consolas"/>
                 <a:cs typeface="Consolas"/>
               </a:rPr>
+              <a:t> (command.</a:t>
+            </a:r>
+            <a:r>
+              <a:rPr sz="1150" b="1">
+                <a:solidFill>
+                  <a:srgbClr val="7F3FBF"/>
+                </a:solidFill>
+                <a:latin typeface="Consolas"/>
+                <a:ea typeface="Consolas"/>
+                <a:cs typeface="Consolas"/>
+              </a:rPr>
+              <a:t>RequestId</a:t>
+            </a:r>
+            <a:r>
+              <a:rPr sz="1150" b="0">
+                <a:solidFill>
+                  <a:srgbClr val="202632"/>
+                </a:solidFill>
+                <a:latin typeface="Consolas"/>
+                <a:ea typeface="Consolas"/>
+                <a:cs typeface="Consolas"/>
+              </a:rPr>
+              <a:t> == </a:t>
+            </a:r>
+            <a:r>
+              <a:rPr sz="1150" b="1">
+                <a:solidFill>
+                  <a:srgbClr val="7F3FBF"/>
+                </a:solidFill>
+                <a:latin typeface="Consolas"/>
+                <a:ea typeface="Consolas"/>
+                <a:cs typeface="Consolas"/>
+              </a:rPr>
+              <a:t>Guid</a:t>
+            </a:r>
+            <a:r>
+              <a:rPr sz="1150" b="0">
+                <a:solidFill>
+                  <a:srgbClr val="202632"/>
+                </a:solidFill>
+                <a:latin typeface="Consolas"/>
+                <a:ea typeface="Consolas"/>
+                <a:cs typeface="Consolas"/>
+              </a:rPr>
+              <a:t>.</a:t>
+            </a:r>
+            <a:r>
+              <a:rPr sz="1150" b="1">
+                <a:solidFill>
+                  <a:srgbClr val="7F3FBF"/>
+                </a:solidFill>
+                <a:latin typeface="Consolas"/>
+                <a:ea typeface="Consolas"/>
+                <a:cs typeface="Consolas"/>
+              </a:rPr>
+              <a:t>Empty</a:t>
+            </a:r>
+            <a:r>
+              <a:rPr sz="1150" b="0">
+                <a:solidFill>
+                  <a:srgbClr val="202632"/>
+                </a:solidFill>
+                <a:latin typeface="Consolas"/>
+                <a:ea typeface="Consolas"/>
+                <a:cs typeface="Consolas"/>
+              </a:rPr>
+              <a:t>)</a:t>
+            </a:r>
+            <a:br/>
+            <a:r>
+              <a:rPr sz="1150">
+                <a:solidFill>
+                  <a:srgbClr val="7A8699"/>
+                </a:solidFill>
+                <a:latin typeface="Consolas"/>
+                <a:ea typeface="Consolas"/>
+                <a:cs typeface="Consolas"/>
+              </a:rPr>
+              <a:t> 5  </a:t>
+            </a:r>
+            <a:r>
+              <a:rPr sz="1150" b="0">
+                <a:solidFill>
+                  <a:srgbClr val="202632"/>
+                </a:solidFill>
+                <a:latin typeface="Consolas"/>
+                <a:ea typeface="Consolas"/>
+                <a:cs typeface="Consolas"/>
+              </a:rPr>
+              <a:t>    </a:t>
+            </a:r>
+            <a:r>
+              <a:rPr sz="1150" b="1">
+                <a:solidFill>
+                  <a:srgbClr val="0563C1"/>
+                </a:solidFill>
+                <a:latin typeface="Consolas"/>
+                <a:ea typeface="Consolas"/>
+                <a:cs typeface="Consolas"/>
+              </a:rPr>
+              <a:t>return</a:t>
+            </a:r>
+            <a:r>
+              <a:rPr sz="1150" b="0">
+                <a:solidFill>
+                  <a:srgbClr val="202632"/>
+                </a:solidFill>
+                <a:latin typeface="Consolas"/>
+                <a:ea typeface="Consolas"/>
+                <a:cs typeface="Consolas"/>
+              </a:rPr>
               <a:t> </a:t>
             </a:r>
             <a:r>
               <a:rPr sz="1150" b="1">
                 <a:solidFill>
+                  <a:srgbClr val="7F3FBF"/>
+                </a:solidFill>
+                <a:latin typeface="Consolas"/>
+                <a:ea typeface="Consolas"/>
+                <a:cs typeface="Consolas"/>
+              </a:rPr>
+              <a:t>Result</a:t>
+            </a:r>
+            <a:r>
+              <a:rPr sz="1150" b="0">
+                <a:solidFill>
+                  <a:srgbClr val="202632"/>
+                </a:solidFill>
+                <a:latin typeface="Consolas"/>
+                <a:ea typeface="Consolas"/>
+                <a:cs typeface="Consolas"/>
+              </a:rPr>
+              <a:t>.</a:t>
+            </a:r>
+            <a:r>
+              <a:rPr sz="1150" b="1">
+                <a:solidFill>
+                  <a:srgbClr val="7F3FBF"/>
+                </a:solidFill>
+                <a:latin typeface="Consolas"/>
+                <a:ea typeface="Consolas"/>
+                <a:cs typeface="Consolas"/>
+              </a:rPr>
+              <a:t>Fail</a:t>
+            </a:r>
+            <a:r>
+              <a:rPr sz="1150" b="0">
+                <a:solidFill>
+                  <a:srgbClr val="202632"/>
+                </a:solidFill>
+                <a:latin typeface="Consolas"/>
+                <a:ea typeface="Consolas"/>
+                <a:cs typeface="Consolas"/>
+              </a:rPr>
+              <a:t>(</a:t>
+            </a:r>
+            <a:br/>
+            <a:r>
+              <a:rPr sz="1150">
+                <a:solidFill>
+                  <a:srgbClr val="7A8699"/>
+                </a:solidFill>
+                <a:latin typeface="Consolas"/>
+                <a:ea typeface="Consolas"/>
+                <a:cs typeface="Consolas"/>
+              </a:rPr>
+              <a:t> 6  </a:t>
+            </a:r>
+            <a:r>
+              <a:rPr sz="1150" b="0">
+                <a:solidFill>
+                  <a:srgbClr val="202632"/>
+                </a:solidFill>
+                <a:latin typeface="Consolas"/>
+                <a:ea typeface="Consolas"/>
+                <a:cs typeface="Consolas"/>
+              </a:rPr>
+              <a:t>      </a:t>
+            </a:r>
+            <a:r>
+              <a:rPr sz="1150" b="1">
+                <a:solidFill>
+                  <a:srgbClr val="7F3FBF"/>
+                </a:solidFill>
+                <a:latin typeface="Consolas"/>
+                <a:ea typeface="Consolas"/>
+                <a:cs typeface="Consolas"/>
+              </a:rPr>
+              <a:t>CreateReservationErrorCodes</a:t>
+            </a:r>
+            <a:r>
+              <a:rPr sz="1150" b="0">
+                <a:solidFill>
+                  <a:srgbClr val="202632"/>
+                </a:solidFill>
+                <a:latin typeface="Consolas"/>
+                <a:ea typeface="Consolas"/>
+                <a:cs typeface="Consolas"/>
+              </a:rPr>
+              <a:t>.</a:t>
+            </a:r>
+            <a:r>
+              <a:rPr sz="1150" b="1">
+                <a:solidFill>
+                  <a:srgbClr val="7F3FBF"/>
+                </a:solidFill>
+                <a:latin typeface="Consolas"/>
+                <a:ea typeface="Consolas"/>
+                <a:cs typeface="Consolas"/>
+              </a:rPr>
+              <a:t>RequestIdRequired</a:t>
+            </a:r>
+            <a:r>
+              <a:rPr sz="1150" b="0">
+                <a:solidFill>
+                  <a:srgbClr val="202632"/>
+                </a:solidFill>
+                <a:latin typeface="Consolas"/>
+                <a:ea typeface="Consolas"/>
+                <a:cs typeface="Consolas"/>
+              </a:rPr>
+              <a:t>);</a:t>
+            </a:r>
+            <a:br/>
+            <a:r>
+              <a:rPr sz="1150">
+                <a:solidFill>
+                  <a:srgbClr val="7A8699"/>
+                </a:solidFill>
+                <a:latin typeface="Consolas"/>
+                <a:ea typeface="Consolas"/>
+                <a:cs typeface="Consolas"/>
+              </a:rPr>
+              <a:t> 7  </a:t>
+            </a:r>
+            <a:r>
+              <a:rPr sz="1150" b="0">
+                <a:solidFill>
+                  <a:srgbClr val="202632"/>
+                </a:solidFill>
+                <a:latin typeface="Consolas"/>
+                <a:ea typeface="Consolas"/>
+                <a:cs typeface="Consolas"/>
+              </a:rPr>
+              <a:t>  </a:t>
+            </a:r>
+            <a:r>
+              <a:rPr sz="1150" b="1">
+                <a:solidFill>
                   <a:srgbClr val="0563C1"/>
                 </a:solidFill>
                 <a:latin typeface="Consolas"/>
                 <a:ea typeface="Consolas"/>
                 <a:cs typeface="Consolas"/>
               </a:rPr>
-              <a:t>void</a:t>
+              <a:t>if</a:t>
             </a:r>
             <a:r>
               <a:rPr sz="1150" b="0">
@@ -25636,6 +26314,95 @@
                 <a:ea typeface="Consolas"/>
                 <a:cs typeface="Consolas"/>
               </a:rPr>
+              <a:t> (command.</a:t>
+            </a:r>
+            <a:r>
+              <a:rPr sz="1150" b="1">
+                <a:solidFill>
+                  <a:srgbClr val="7F3FBF"/>
+                </a:solidFill>
+                <a:latin typeface="Consolas"/>
+                <a:ea typeface="Consolas"/>
+                <a:cs typeface="Consolas"/>
+              </a:rPr>
+              <a:t>Quantity</a:t>
+            </a:r>
+            <a:r>
+              <a:rPr sz="1150" b="0">
+                <a:solidFill>
+                  <a:srgbClr val="202632"/>
+                </a:solidFill>
+                <a:latin typeface="Consolas"/>
+                <a:ea typeface="Consolas"/>
+                <a:cs typeface="Consolas"/>
+              </a:rPr>
+              <a:t> &lt;= </a:t>
+            </a:r>
+            <a:r>
+              <a:rPr sz="1150" b="0">
+                <a:solidFill>
+                  <a:srgbClr val="7A8699"/>
+                </a:solidFill>
+                <a:latin typeface="Consolas"/>
+                <a:ea typeface="Consolas"/>
+                <a:cs typeface="Consolas"/>
+              </a:rPr>
+              <a:t>0</a:t>
+            </a:r>
+            <a:r>
+              <a:rPr sz="1150" b="0">
+                <a:solidFill>
+                  <a:srgbClr val="202632"/>
+                </a:solidFill>
+                <a:latin typeface="Consolas"/>
+                <a:ea typeface="Consolas"/>
+                <a:cs typeface="Consolas"/>
+              </a:rPr>
+              <a:t>)</a:t>
+            </a:r>
+            <a:br/>
+            <a:r>
+              <a:rPr sz="1150">
+                <a:solidFill>
+                  <a:srgbClr val="7A8699"/>
+                </a:solidFill>
+                <a:latin typeface="Consolas"/>
+                <a:ea typeface="Consolas"/>
+                <a:cs typeface="Consolas"/>
+              </a:rPr>
+              <a:t> 8  </a:t>
+            </a:r>
+            <a:r>
+              <a:rPr sz="1150" b="0">
+                <a:solidFill>
+                  <a:srgbClr val="202632"/>
+                </a:solidFill>
+                <a:latin typeface="Consolas"/>
+                <a:ea typeface="Consolas"/>
+                <a:cs typeface="Consolas"/>
+              </a:rPr>
+              <a:t>    </a:t>
+            </a:r>
+            <a:r>
+              <a:rPr sz="1150" b="1">
+                <a:solidFill>
+                  <a:srgbClr val="0563C1"/>
+                </a:solidFill>
+                <a:latin typeface="Consolas"/>
+                <a:ea typeface="Consolas"/>
+                <a:cs typeface="Consolas"/>
+              </a:rPr>
+              <a:t>return</a:t>
+            </a:r>
+            <a:r>
+              <a:rPr sz="1150" b="0">
+                <a:solidFill>
+                  <a:srgbClr val="202632"/>
+                </a:solidFill>
+                <a:latin typeface="Consolas"/>
+                <a:ea typeface="Consolas"/>
+                <a:cs typeface="Consolas"/>
+              </a:rPr>
               <a:t> </a:t>
             </a:r>
             <a:r>
@@ -25647,7 +26414,7 @@
                 <a:ea typeface="Consolas"/>
                 <a:cs typeface="Consolas"/>
               </a:rPr>
-              <a:t>ValidateAndThrow</a:t>
+              <a:t>Result</a:t>
             </a:r>
             <a:r>
               <a:rPr sz="1150" b="0">
@@ -25658,6 +26425,28 @@
                 <a:ea typeface="Consolas"/>
                 <a:cs typeface="Consolas"/>
               </a:rPr>
+              <a:t>.</a:t>
+            </a:r>
+            <a:r>
+              <a:rPr sz="1150" b="1">
+                <a:solidFill>
+                  <a:srgbClr val="7F3FBF"/>
+                </a:solidFill>
+                <a:latin typeface="Consolas"/>
+                <a:ea typeface="Consolas"/>
+                <a:cs typeface="Consolas"/>
+              </a:rPr>
+              <a:t>Fail</a:t>
+            </a:r>
+            <a:r>
+              <a:rPr sz="1150" b="0">
+                <a:solidFill>
+                  <a:srgbClr val="202632"/>
+                </a:solidFill>
+                <a:latin typeface="Consolas"/>
+                <a:ea typeface="Consolas"/>
+                <a:cs typeface="Consolas"/>
+              </a:rPr>
               <a:t>(</a:t>
             </a:r>
             <a:br/>
@@ -25670,7 +26459,7 @@
                 <a:ea typeface="Consolas"/>
                 <a:cs typeface="Consolas"/>
               </a:rPr>
-              <a:t> 2  </a:t>
+              <a:t> 9  </a:t>
             </a:r>
             <a:r>
               <a:rPr sz="1150" b="0">
@@ -25681,7 +26470,7 @@
                 <a:ea typeface="Consolas"/>
                 <a:cs typeface="Consolas"/>
               </a:rPr>
-              <a:t>    </a:t>
+              <a:t>      </a:t>
             </a:r>
             <a:r>
               <a:rPr sz="1150" b="1">
@@ -25692,7 +26481,7 @@
                 <a:ea typeface="Consolas"/>
                 <a:cs typeface="Consolas"/>
               </a:rPr>
-              <a:t>CreateReservationCommand</a:t>
+              <a:t>CreateReservationErrorCodes</a:t>
             </a:r>
             <a:r>
               <a:rPr sz="1150" b="0">
@@ -25703,7 +26492,29 @@
                 <a:ea typeface="Consolas"/>
                 <a:cs typeface="Consolas"/>
               </a:rPr>
-              <a:t> command)</a:t>
+              <a:t>.</a:t>
+            </a:r>
+            <a:r>
+              <a:rPr sz="1150" b="1">
+                <a:solidFill>
+                  <a:srgbClr val="7F3FBF"/>
+                </a:solidFill>
+                <a:latin typeface="Consolas"/>
+                <a:ea typeface="Consolas"/>
+                <a:cs typeface="Consolas"/>
+              </a:rPr>
+              <a:t>QuantityMustBePositive</a:t>
+            </a:r>
+            <a:r>
+              <a:rPr sz="1150" b="0">
+                <a:solidFill>
+                  <a:srgbClr val="202632"/>
+                </a:solidFill>
+                <a:latin typeface="Consolas"/>
+                <a:ea typeface="Consolas"/>
+                <a:cs typeface="Consolas"/>
+              </a:rPr>
+              <a:t>);</a:t>
             </a:r>
             <a:br/>
             <a:r>
@@ -25715,7 +26526,7 @@
                 <a:ea typeface="Consolas"/>
                 <a:cs typeface="Consolas"/>
               </a:rPr>
-              <a:t> 3  </a:t>
+              <a:t>10  </a:t>
             </a:r>
             <a:r>
               <a:rPr sz="1150" b="0">
@@ -25726,19 +26537,18 @@
                 <a:ea typeface="Consolas"/>
                 <a:cs typeface="Consolas"/>
               </a:rPr>
-              <a:t>{</a:t>
-            </a:r>
-            <a:br/>
-            <a:r>
-              <a:rPr sz="1150">
-                <a:solidFill>
-                  <a:srgbClr val="7A8699"/>
-                </a:solidFill>
-                <a:latin typeface="Consolas"/>
-                <a:ea typeface="Consolas"/>
-                <a:cs typeface="Consolas"/>
-              </a:rPr>
-              <a:t> 4  </a:t>
+              <a:t>  </a:t>
+            </a:r>
+            <a:r>
+              <a:rPr sz="1150" b="1">
+                <a:solidFill>
+                  <a:srgbClr val="0563C1"/>
+                </a:solidFill>
+                <a:latin typeface="Consolas"/>
+                <a:ea typeface="Consolas"/>
+                <a:cs typeface="Consolas"/>
+              </a:rPr>
+              <a:t>return</a:t>
             </a:r>
             <a:r>
               <a:rPr sz="1150" b="0">
@@ -25749,7 +26559,7 @@
                 <a:ea typeface="Consolas"/>
                 <a:cs typeface="Consolas"/>
               </a:rPr>
-              <a:t>  </a:t>
+              <a:t> </a:t>
             </a:r>
             <a:r>
               <a:rPr sz="1150" b="1">
@@ -25760,7 +26570,7 @@
                 <a:ea typeface="Consolas"/>
                 <a:cs typeface="Consolas"/>
               </a:rPr>
-              <a:t>ArgumentNullException</a:t>
+              <a:t>Result</a:t>
             </a:r>
             <a:r>
               <a:rPr sz="1150" b="0">
@@ -25782,7 +26592,7 @@
                 <a:ea typeface="Consolas"/>
                 <a:cs typeface="Consolas"/>
               </a:rPr>
-              <a:t>ThrowIfNull</a:t>
+              <a:t>Ok</a:t>
             </a:r>
             <a:r>
               <a:rPr sz="1150" b="0">
@@ -25793,453 +26603,7 @@
                 <a:ea typeface="Consolas"/>
                 <a:cs typeface="Consolas"/>
               </a:rPr>
-              <a:t>(command);</a:t>
-            </a:r>
-            <a:br/>
-            <a:r>
-              <a:rPr sz="1150">
-                <a:solidFill>
-                  <a:srgbClr val="7A8699"/>
-                </a:solidFill>
-                <a:latin typeface="Consolas"/>
-                <a:ea typeface="Consolas"/>
-                <a:cs typeface="Consolas"/>
-              </a:rPr>
-              <a:t> 5  </a:t>
-            </a:r>
-            <a:r>
-              <a:rPr sz="1150" b="0">
-                <a:solidFill>
-                  <a:srgbClr val="202632"/>
-                </a:solidFill>
-                <a:latin typeface="Consolas"/>
-                <a:ea typeface="Consolas"/>
-                <a:cs typeface="Consolas"/>
-              </a:rPr>
-              <a:t>  </a:t>
-            </a:r>
-            <a:r>
-              <a:rPr sz="1150" b="1">
-                <a:solidFill>
-                  <a:srgbClr val="0563C1"/>
-                </a:solidFill>
-                <a:latin typeface="Consolas"/>
-                <a:ea typeface="Consolas"/>
-                <a:cs typeface="Consolas"/>
-              </a:rPr>
-              <a:t>if</a:t>
-            </a:r>
-            <a:r>
-              <a:rPr sz="1150" b="0">
-                <a:solidFill>
-                  <a:srgbClr val="202632"/>
-                </a:solidFill>
-                <a:latin typeface="Consolas"/>
-                <a:ea typeface="Consolas"/>
-                <a:cs typeface="Consolas"/>
-              </a:rPr>
-              <a:t> (command.</a:t>
-            </a:r>
-            <a:r>
-              <a:rPr sz="1150" b="1">
-                <a:solidFill>
-                  <a:srgbClr val="7F3FBF"/>
-                </a:solidFill>
-                <a:latin typeface="Consolas"/>
-                <a:ea typeface="Consolas"/>
-                <a:cs typeface="Consolas"/>
-              </a:rPr>
-              <a:t>RequestId</a:t>
-            </a:r>
-            <a:r>
-              <a:rPr sz="1150" b="0">
-                <a:solidFill>
-                  <a:srgbClr val="202632"/>
-                </a:solidFill>
-                <a:latin typeface="Consolas"/>
-                <a:ea typeface="Consolas"/>
-                <a:cs typeface="Consolas"/>
-              </a:rPr>
-              <a:t> == </a:t>
-            </a:r>
-            <a:r>
-              <a:rPr sz="1150" b="1">
-                <a:solidFill>
-                  <a:srgbClr val="7F3FBF"/>
-                </a:solidFill>
-                <a:latin typeface="Consolas"/>
-                <a:ea typeface="Consolas"/>
-                <a:cs typeface="Consolas"/>
-              </a:rPr>
-              <a:t>Guid</a:t>
-            </a:r>
-            <a:r>
-              <a:rPr sz="1150" b="0">
-                <a:solidFill>
-                  <a:srgbClr val="202632"/>
-                </a:solidFill>
-                <a:latin typeface="Consolas"/>
-                <a:ea typeface="Consolas"/>
-                <a:cs typeface="Consolas"/>
-              </a:rPr>
-              <a:t>.</a:t>
-            </a:r>
-            <a:r>
-              <a:rPr sz="1150" b="1">
-                <a:solidFill>
-                  <a:srgbClr val="7F3FBF"/>
-                </a:solidFill>
-                <a:latin typeface="Consolas"/>
-                <a:ea typeface="Consolas"/>
-                <a:cs typeface="Consolas"/>
-              </a:rPr>
-              <a:t>Empty</a:t>
-            </a:r>
-            <a:r>
-              <a:rPr sz="1150" b="0">
-                <a:solidFill>
-                  <a:srgbClr val="202632"/>
-                </a:solidFill>
-                <a:latin typeface="Consolas"/>
-                <a:ea typeface="Consolas"/>
-                <a:cs typeface="Consolas"/>
-              </a:rPr>
-              <a:t>)</a:t>
-            </a:r>
-            <a:br/>
-            <a:r>
-              <a:rPr sz="1150">
-                <a:solidFill>
-                  <a:srgbClr val="7A8699"/>
-                </a:solidFill>
-                <a:latin typeface="Consolas"/>
-                <a:ea typeface="Consolas"/>
-                <a:cs typeface="Consolas"/>
-              </a:rPr>
-              <a:t> 6  </a:t>
-            </a:r>
-            <a:r>
-              <a:rPr sz="1150" b="0">
-                <a:solidFill>
-                  <a:srgbClr val="202632"/>
-                </a:solidFill>
-                <a:latin typeface="Consolas"/>
-                <a:ea typeface="Consolas"/>
-                <a:cs typeface="Consolas"/>
-              </a:rPr>
-              <a:t>    </a:t>
-            </a:r>
-            <a:r>
-              <a:rPr sz="1150" b="1">
-                <a:solidFill>
-                  <a:srgbClr val="0563C1"/>
-                </a:solidFill>
-                <a:latin typeface="Consolas"/>
-                <a:ea typeface="Consolas"/>
-                <a:cs typeface="Consolas"/>
-              </a:rPr>
-              <a:t>throw</a:t>
-            </a:r>
-            <a:r>
-              <a:rPr sz="1150" b="0">
-                <a:solidFill>
-                  <a:srgbClr val="202632"/>
-                </a:solidFill>
-                <a:latin typeface="Consolas"/>
-                <a:ea typeface="Consolas"/>
-                <a:cs typeface="Consolas"/>
-              </a:rPr>
-              <a:t> </a:t>
-            </a:r>
-            <a:r>
-              <a:rPr sz="1150" b="1">
-                <a:solidFill>
-                  <a:srgbClr val="0563C1"/>
-                </a:solidFill>
-                <a:latin typeface="Consolas"/>
-                <a:ea typeface="Consolas"/>
-                <a:cs typeface="Consolas"/>
-              </a:rPr>
-              <a:t>new</a:t>
-            </a:r>
-            <a:r>
-              <a:rPr sz="1150" b="0">
-                <a:solidFill>
-                  <a:srgbClr val="202632"/>
-                </a:solidFill>
-                <a:latin typeface="Consolas"/>
-                <a:ea typeface="Consolas"/>
-                <a:cs typeface="Consolas"/>
-              </a:rPr>
-              <a:t> </a:t>
-            </a:r>
-            <a:r>
-              <a:rPr sz="1150" b="1">
-                <a:solidFill>
-                  <a:srgbClr val="7F3FBF"/>
-                </a:solidFill>
-                <a:latin typeface="Consolas"/>
-                <a:ea typeface="Consolas"/>
-                <a:cs typeface="Consolas"/>
-              </a:rPr>
-              <a:t>ArgumentException</a:t>
-            </a:r>
-            <a:r>
-              <a:rPr sz="1150" b="0">
-                <a:solidFill>
-                  <a:srgbClr val="202632"/>
-                </a:solidFill>
-                <a:latin typeface="Consolas"/>
-                <a:ea typeface="Consolas"/>
-                <a:cs typeface="Consolas"/>
-              </a:rPr>
-              <a:t>(</a:t>
-            </a:r>
-            <a:br/>
-            <a:r>
-              <a:rPr sz="1150">
-                <a:solidFill>
-                  <a:srgbClr val="7A8699"/>
-                </a:solidFill>
-                <a:latin typeface="Consolas"/>
-                <a:ea typeface="Consolas"/>
-                <a:cs typeface="Consolas"/>
-              </a:rPr>
-              <a:t> 7  </a:t>
-            </a:r>
-            <a:r>
-              <a:rPr sz="1150" b="0">
-                <a:solidFill>
-                  <a:srgbClr val="202632"/>
-                </a:solidFill>
-                <a:latin typeface="Consolas"/>
-                <a:ea typeface="Consolas"/>
-                <a:cs typeface="Consolas"/>
-              </a:rPr>
-              <a:t>      </a:t>
-            </a:r>
-            <a:r>
-              <a:rPr sz="1150" b="0">
-                <a:solidFill>
-                  <a:srgbClr val="C65911"/>
-                </a:solidFill>
-                <a:latin typeface="Consolas"/>
-                <a:ea typeface="Consolas"/>
-                <a:cs typeface="Consolas"/>
-              </a:rPr>
-              <a:t>"Request id is required."</a:t>
-            </a:r>
-            <a:r>
-              <a:rPr sz="1150" b="0">
-                <a:solidFill>
-                  <a:srgbClr val="202632"/>
-                </a:solidFill>
-                <a:latin typeface="Consolas"/>
-                <a:ea typeface="Consolas"/>
-                <a:cs typeface="Consolas"/>
-              </a:rPr>
-              <a:t>);</a:t>
-            </a:r>
-            <a:br/>
-            <a:r>
-              <a:rPr sz="1150">
-                <a:solidFill>
-                  <a:srgbClr val="7A8699"/>
-                </a:solidFill>
-                <a:latin typeface="Consolas"/>
-                <a:ea typeface="Consolas"/>
-                <a:cs typeface="Consolas"/>
-              </a:rPr>
-              <a:t> 8  </a:t>
-            </a:r>
-            <a:r>
-              <a:rPr sz="1150" b="0">
-                <a:solidFill>
-                  <a:srgbClr val="202632"/>
-                </a:solidFill>
-                <a:latin typeface="Consolas"/>
-                <a:ea typeface="Consolas"/>
-                <a:cs typeface="Consolas"/>
-              </a:rPr>
-              <a:t>  </a:t>
-            </a:r>
-            <a:r>
-              <a:rPr sz="1150" b="1">
-                <a:solidFill>
-                  <a:srgbClr val="0563C1"/>
-                </a:solidFill>
-                <a:latin typeface="Consolas"/>
-                <a:ea typeface="Consolas"/>
-                <a:cs typeface="Consolas"/>
-              </a:rPr>
-              <a:t>if</a:t>
-            </a:r>
-            <a:r>
-              <a:rPr sz="1150" b="0">
-                <a:solidFill>
-                  <a:srgbClr val="202632"/>
-                </a:solidFill>
-                <a:latin typeface="Consolas"/>
-                <a:ea typeface="Consolas"/>
-                <a:cs typeface="Consolas"/>
-              </a:rPr>
-              <a:t> (command.</a:t>
-            </a:r>
-            <a:r>
-              <a:rPr sz="1150" b="1">
-                <a:solidFill>
-                  <a:srgbClr val="7F3FBF"/>
-                </a:solidFill>
-                <a:latin typeface="Consolas"/>
-                <a:ea typeface="Consolas"/>
-                <a:cs typeface="Consolas"/>
-              </a:rPr>
-              <a:t>Quantity</a:t>
-            </a:r>
-            <a:r>
-              <a:rPr sz="1150" b="0">
-                <a:solidFill>
-                  <a:srgbClr val="202632"/>
-                </a:solidFill>
-                <a:latin typeface="Consolas"/>
-                <a:ea typeface="Consolas"/>
-                <a:cs typeface="Consolas"/>
-              </a:rPr>
-              <a:t> &lt;= </a:t>
-            </a:r>
-            <a:r>
-              <a:rPr sz="1150" b="0">
-                <a:solidFill>
-                  <a:srgbClr val="7A8699"/>
-                </a:solidFill>
-                <a:latin typeface="Consolas"/>
-                <a:ea typeface="Consolas"/>
-                <a:cs typeface="Consolas"/>
-              </a:rPr>
-              <a:t>0</a:t>
-            </a:r>
-            <a:r>
-              <a:rPr sz="1150" b="0">
-                <a:solidFill>
-                  <a:srgbClr val="202632"/>
-                </a:solidFill>
-                <a:latin typeface="Consolas"/>
-                <a:ea typeface="Consolas"/>
-                <a:cs typeface="Consolas"/>
-              </a:rPr>
-              <a:t>)</a:t>
-            </a:r>
-            <a:br/>
-            <a:r>
-              <a:rPr sz="1150">
-                <a:solidFill>
-                  <a:srgbClr val="7A8699"/>
-                </a:solidFill>
-                <a:latin typeface="Consolas"/>
-                <a:ea typeface="Consolas"/>
-                <a:cs typeface="Consolas"/>
-              </a:rPr>
-              <a:t> 9  </a:t>
-            </a:r>
-            <a:r>
-              <a:rPr sz="1150" b="0">
-                <a:solidFill>
-                  <a:srgbClr val="202632"/>
-                </a:solidFill>
-                <a:latin typeface="Consolas"/>
-                <a:ea typeface="Consolas"/>
-                <a:cs typeface="Consolas"/>
-              </a:rPr>
-              <a:t>    </a:t>
-            </a:r>
-            <a:r>
-              <a:rPr sz="1150" b="1">
-                <a:solidFill>
-                  <a:srgbClr val="0563C1"/>
-                </a:solidFill>
-                <a:latin typeface="Consolas"/>
-                <a:ea typeface="Consolas"/>
-                <a:cs typeface="Consolas"/>
-              </a:rPr>
-              <a:t>throw</a:t>
-            </a:r>
-            <a:r>
-              <a:rPr sz="1150" b="0">
-                <a:solidFill>
-                  <a:srgbClr val="202632"/>
-                </a:solidFill>
-                <a:latin typeface="Consolas"/>
-                <a:ea typeface="Consolas"/>
-                <a:cs typeface="Consolas"/>
-              </a:rPr>
-              <a:t> </a:t>
-            </a:r>
-            <a:r>
-              <a:rPr sz="1150" b="1">
-                <a:solidFill>
-                  <a:srgbClr val="0563C1"/>
-                </a:solidFill>
-                <a:latin typeface="Consolas"/>
-                <a:ea typeface="Consolas"/>
-                <a:cs typeface="Consolas"/>
-              </a:rPr>
-              <a:t>new</a:t>
-            </a:r>
-            <a:r>
-              <a:rPr sz="1150" b="0">
-                <a:solidFill>
-                  <a:srgbClr val="202632"/>
-                </a:solidFill>
-                <a:latin typeface="Consolas"/>
-                <a:ea typeface="Consolas"/>
-                <a:cs typeface="Consolas"/>
-              </a:rPr>
-              <a:t> </a:t>
-            </a:r>
-            <a:r>
-              <a:rPr sz="1150" b="1">
-                <a:solidFill>
-                  <a:srgbClr val="7F3FBF"/>
-                </a:solidFill>
-                <a:latin typeface="Consolas"/>
-                <a:ea typeface="Consolas"/>
-                <a:cs typeface="Consolas"/>
-              </a:rPr>
-              <a:t>ArgumentOutOfRangeException</a:t>
-            </a:r>
-            <a:r>
-              <a:rPr sz="1150" b="0">
-                <a:solidFill>
-                  <a:srgbClr val="202632"/>
-                </a:solidFill>
-                <a:latin typeface="Consolas"/>
-                <a:ea typeface="Consolas"/>
-                <a:cs typeface="Consolas"/>
-              </a:rPr>
-              <a:t>(</a:t>
-            </a:r>
-            <a:br/>
-            <a:r>
-              <a:rPr sz="1150">
-                <a:solidFill>
-                  <a:srgbClr val="7A8699"/>
-                </a:solidFill>
-                <a:latin typeface="Consolas"/>
-                <a:ea typeface="Consolas"/>
-                <a:cs typeface="Consolas"/>
-              </a:rPr>
-              <a:t>10  </a:t>
-            </a:r>
-            <a:r>
-              <a:rPr sz="1150" b="0">
-                <a:solidFill>
-                  <a:srgbClr val="202632"/>
-                </a:solidFill>
-                <a:latin typeface="Consolas"/>
-                <a:ea typeface="Consolas"/>
-                <a:cs typeface="Consolas"/>
-              </a:rPr>
-              <a:t>      nameof(command));</a:t>
+              <a:t>();</a:t>
             </a:r>
             <a:br/>
             <a:r>
@@ -27859,7 +28223,30 @@
                 <a:ea typeface="Consolas"/>
                 <a:cs typeface="Consolas"/>
               </a:rPr>
-              <a:t>, </a:t>
+              <a:t>,</a:t>
+            </a:r>
+            <a:br/>
+            <a:r>
+              <a:rPr sz="1120">
+                <a:solidFill>
+                  <a:srgbClr val="7A8699"/>
+                </a:solidFill>
+                <a:latin typeface="Consolas"/>
+                <a:ea typeface="Consolas"/>
+                <a:cs typeface="Consolas"/>
+              </a:rPr>
+              <a:t> 3  </a:t>
+            </a:r>
+            <a:r>
+              <a:rPr sz="1120" b="0">
+                <a:solidFill>
+                  <a:srgbClr val="202632"/>
+                </a:solidFill>
+                <a:latin typeface="Consolas"/>
+                <a:ea typeface="Consolas"/>
+                <a:cs typeface="Consolas"/>
+              </a:rPr>
+              <a:t>  </a:t>
             </a:r>
             <a:r>
               <a:rPr sz="1120" b="1">
@@ -27903,7 +28290,30 @@
                 <a:ea typeface="Consolas"/>
                 <a:cs typeface="Consolas"/>
               </a:rPr>
-              <a:t>, </a:t>
+              <a:t>,</a:t>
+            </a:r>
+            <a:br/>
+            <a:r>
+              <a:rPr sz="1120">
+                <a:solidFill>
+                  <a:srgbClr val="7A8699"/>
+                </a:solidFill>
+                <a:latin typeface="Consolas"/>
+                <a:ea typeface="Consolas"/>
+                <a:cs typeface="Consolas"/>
+              </a:rPr>
+              <a:t> 4  </a:t>
+            </a:r>
+            <a:r>
+              <a:rPr sz="1120" b="0">
+                <a:solidFill>
+                  <a:srgbClr val="202632"/>
+                </a:solidFill>
+                <a:latin typeface="Consolas"/>
+                <a:ea typeface="Consolas"/>
+                <a:cs typeface="Consolas"/>
+              </a:rPr>
+              <a:t>  </a:t>
             </a:r>
             <a:r>
               <a:rPr sz="1120" b="1">
@@ -27959,7 +28369,7 @@
                 <a:ea typeface="Consolas"/>
                 <a:cs typeface="Consolas"/>
               </a:rPr>
-              <a:t> 3  </a:t>
+              <a:t> 5  </a:t>
             </a:r>
             <a:br/>
             <a:r>
@@ -27971,7 +28381,7 @@
                 <a:ea typeface="Consolas"/>
                 <a:cs typeface="Consolas"/>
               </a:rPr>
-              <a:t> 4  </a:t>
+              <a:t> 6  </a:t>
             </a:r>
             <a:r>
               <a:rPr sz="1120" b="1">
@@ -28004,7 +28414,7 @@
                 <a:ea typeface="Consolas"/>
                 <a:cs typeface="Consolas"/>
               </a:rPr>
-              <a:t>sealed</a:t>
+              <a:t>interface</a:t>
             </a:r>
             <a:r>
               <a:rPr sz="1120" b="0">
@@ -28020,13 +28430,25 @@
             <a:r>
               <a:rPr sz="1120" b="1">
                 <a:solidFill>
-                  <a:srgbClr val="0563C1"/>
-                </a:solidFill>
-                <a:latin typeface="Consolas"/>
-                <a:ea typeface="Consolas"/>
-                <a:cs typeface="Consolas"/>
-              </a:rPr>
-              <a:t>record</a:t>
+                  <a:srgbClr val="7F3FBF"/>
+                </a:solidFill>
+                <a:latin typeface="Consolas"/>
+                <a:ea typeface="Consolas"/>
+                <a:cs typeface="Consolas"/>
+              </a:rPr>
+              <a:t>IInventoryModule</a:t>
+            </a:r>
+            <a:br/>
+            <a:r>
+              <a:rPr sz="1120">
+                <a:solidFill>
+                  <a:srgbClr val="7A8699"/>
+                </a:solidFill>
+                <a:latin typeface="Consolas"/>
+                <a:ea typeface="Consolas"/>
+                <a:cs typeface="Consolas"/>
+              </a:rPr>
+              <a:t> 7  </a:t>
             </a:r>
             <a:r>
               <a:rPr sz="1120" b="0">
@@ -28037,7 +28459,30 @@
                 <a:ea typeface="Consolas"/>
                 <a:cs typeface="Consolas"/>
               </a:rPr>
-              <a:t> </a:t>
+              <a:t>{</a:t>
+            </a:r>
+            <a:br/>
+            <a:r>
+              <a:rPr sz="1120">
+                <a:solidFill>
+                  <a:srgbClr val="7A8699"/>
+                </a:solidFill>
+                <a:latin typeface="Consolas"/>
+                <a:ea typeface="Consolas"/>
+                <a:cs typeface="Consolas"/>
+              </a:rPr>
+              <a:t> 8  </a:t>
+            </a:r>
+            <a:r>
+              <a:rPr sz="1120" b="0">
+                <a:solidFill>
+                  <a:srgbClr val="202632"/>
+                </a:solidFill>
+                <a:latin typeface="Consolas"/>
+                <a:ea typeface="Consolas"/>
+                <a:cs typeface="Consolas"/>
+              </a:rPr>
+              <a:t>  </a:t>
             </a:r>
             <a:r>
               <a:rPr sz="1120" b="1">
@@ -28048,7 +28493,7 @@
                 <a:ea typeface="Consolas"/>
                 <a:cs typeface="Consolas"/>
               </a:rPr>
-              <a:t>ReserveInventoryResult</a:t>
+              <a:t>Task</a:t>
             </a:r>
             <a:r>
               <a:rPr sz="1120" b="0">
@@ -28059,6 +28504,50 @@
                 <a:ea typeface="Consolas"/>
                 <a:cs typeface="Consolas"/>
               </a:rPr>
+              <a:t>&lt;</a:t>
+            </a:r>
+            <a:r>
+              <a:rPr sz="1120" b="1">
+                <a:solidFill>
+                  <a:srgbClr val="7F3FBF"/>
+                </a:solidFill>
+                <a:latin typeface="Consolas"/>
+                <a:ea typeface="Consolas"/>
+                <a:cs typeface="Consolas"/>
+              </a:rPr>
+              <a:t>Result</a:t>
+            </a:r>
+            <a:r>
+              <a:rPr sz="1120" b="0">
+                <a:solidFill>
+                  <a:srgbClr val="202632"/>
+                </a:solidFill>
+                <a:latin typeface="Consolas"/>
+                <a:ea typeface="Consolas"/>
+                <a:cs typeface="Consolas"/>
+              </a:rPr>
+              <a:t>&gt; </a:t>
+            </a:r>
+            <a:r>
+              <a:rPr sz="1120" b="1">
+                <a:solidFill>
+                  <a:srgbClr val="7F3FBF"/>
+                </a:solidFill>
+                <a:latin typeface="Consolas"/>
+                <a:ea typeface="Consolas"/>
+                <a:cs typeface="Consolas"/>
+              </a:rPr>
+              <a:t>ReserveAsync</a:t>
+            </a:r>
+            <a:r>
+              <a:rPr sz="1120" b="0">
+                <a:solidFill>
+                  <a:srgbClr val="202632"/>
+                </a:solidFill>
+                <a:latin typeface="Consolas"/>
+                <a:ea typeface="Consolas"/>
+                <a:cs typeface="Consolas"/>
+              </a:rPr>
               <a:t>(</a:t>
             </a:r>
             <a:br/>
@@ -28071,7 +28560,7 @@
                 <a:ea typeface="Consolas"/>
                 <a:cs typeface="Consolas"/>
               </a:rPr>
-              <a:t> 5  </a:t>
+              <a:t> 9  </a:t>
             </a:r>
             <a:r>
               <a:rPr sz="1120" b="0">
@@ -28082,18 +28571,18 @@
                 <a:ea typeface="Consolas"/>
                 <a:cs typeface="Consolas"/>
               </a:rPr>
-              <a:t>  </a:t>
+              <a:t>    </a:t>
             </a:r>
             <a:r>
               <a:rPr sz="1120" b="1">
                 <a:solidFill>
-                  <a:srgbClr val="0563C1"/>
-                </a:solidFill>
-                <a:latin typeface="Consolas"/>
-                <a:ea typeface="Consolas"/>
-                <a:cs typeface="Consolas"/>
-              </a:rPr>
-              <a:t>bool</a:t>
+                  <a:srgbClr val="7F3FBF"/>
+                </a:solidFill>
+                <a:latin typeface="Consolas"/>
+                <a:ea typeface="Consolas"/>
+                <a:cs typeface="Consolas"/>
+              </a:rPr>
+              <a:t>ReserveInventoryRequest</a:t>
             </a:r>
             <a:r>
               <a:rPr sz="1120" b="0">
@@ -28104,7 +28593,30 @@
                 <a:ea typeface="Consolas"/>
                 <a:cs typeface="Consolas"/>
               </a:rPr>
-              <a:t> </a:t>
+              <a:t> request,</a:t>
+            </a:r>
+            <a:br/>
+            <a:r>
+              <a:rPr sz="1120">
+                <a:solidFill>
+                  <a:srgbClr val="7A8699"/>
+                </a:solidFill>
+                <a:latin typeface="Consolas"/>
+                <a:ea typeface="Consolas"/>
+                <a:cs typeface="Consolas"/>
+              </a:rPr>
+              <a:t>10  </a:t>
+            </a:r>
+            <a:r>
+              <a:rPr sz="1120" b="0">
+                <a:solidFill>
+                  <a:srgbClr val="202632"/>
+                </a:solidFill>
+                <a:latin typeface="Consolas"/>
+                <a:ea typeface="Consolas"/>
+                <a:cs typeface="Consolas"/>
+              </a:rPr>
+              <a:t>    </a:t>
             </a:r>
             <a:r>
               <a:rPr sz="1120" b="1">
@@ -28115,7 +28627,7 @@
                 <a:ea typeface="Consolas"/>
                 <a:cs typeface="Consolas"/>
               </a:rPr>
-              <a:t>Success</a:t>
+              <a:t>CancellationToken</a:t>
             </a:r>
             <a:r>
               <a:rPr sz="1120" b="0">
@@ -28126,51 +28638,7 @@
                 <a:ea typeface="Consolas"/>
                 <a:cs typeface="Consolas"/>
               </a:rPr>
-              <a:t>, </a:t>
-            </a:r>
-            <a:r>
-              <a:rPr sz="1120" b="1">
-                <a:solidFill>
-                  <a:srgbClr val="0563C1"/>
-                </a:solidFill>
-                <a:latin typeface="Consolas"/>
-                <a:ea typeface="Consolas"/>
-                <a:cs typeface="Consolas"/>
-              </a:rPr>
-              <a:t>string</a:t>
-            </a:r>
-            <a:r>
-              <a:rPr sz="1120" b="0">
-                <a:solidFill>
-                  <a:srgbClr val="202632"/>
-                </a:solidFill>
-                <a:latin typeface="Consolas"/>
-                <a:ea typeface="Consolas"/>
-                <a:cs typeface="Consolas"/>
-              </a:rPr>
-              <a:t>? </a:t>
-            </a:r>
-            <a:r>
-              <a:rPr sz="1120" b="1">
-                <a:solidFill>
-                  <a:srgbClr val="7F3FBF"/>
-                </a:solidFill>
-                <a:latin typeface="Consolas"/>
-                <a:ea typeface="Consolas"/>
-                <a:cs typeface="Consolas"/>
-              </a:rPr>
-              <a:t>ErrorCode</a:t>
-            </a:r>
-            <a:r>
-              <a:rPr sz="1120" b="0">
-                <a:solidFill>
-                  <a:srgbClr val="202632"/>
-                </a:solidFill>
-                <a:latin typeface="Consolas"/>
-                <a:ea typeface="Consolas"/>
-                <a:cs typeface="Consolas"/>
-              </a:rPr>
-              <a:t>);</a:t>
+              <a:t> cancellationToken);</a:t>
             </a:r>
             <a:br/>
             <a:r>
@@ -28182,288 +28650,7 @@
                 <a:ea typeface="Consolas"/>
                 <a:cs typeface="Consolas"/>
               </a:rPr>
-              <a:t> 6  </a:t>
-            </a:r>
-            <a:br/>
-            <a:r>
-              <a:rPr sz="1120">
-                <a:solidFill>
-                  <a:srgbClr val="7A8699"/>
-                </a:solidFill>
-                <a:latin typeface="Consolas"/>
-                <a:ea typeface="Consolas"/>
-                <a:cs typeface="Consolas"/>
-              </a:rPr>
-              <a:t> 7  </a:t>
-            </a:r>
-            <a:r>
-              <a:rPr sz="1120" b="1">
-                <a:solidFill>
-                  <a:srgbClr val="0563C1"/>
-                </a:solidFill>
-                <a:latin typeface="Consolas"/>
-                <a:ea typeface="Consolas"/>
-                <a:cs typeface="Consolas"/>
-              </a:rPr>
-              <a:t>public</a:t>
-            </a:r>
-            <a:r>
-              <a:rPr sz="1120" b="0">
-                <a:solidFill>
-                  <a:srgbClr val="202632"/>
-                </a:solidFill>
-                <a:latin typeface="Consolas"/>
-                <a:ea typeface="Consolas"/>
-                <a:cs typeface="Consolas"/>
-              </a:rPr>
-              <a:t> </a:t>
-            </a:r>
-            <a:r>
-              <a:rPr sz="1120" b="1">
-                <a:solidFill>
-                  <a:srgbClr val="0563C1"/>
-                </a:solidFill>
-                <a:latin typeface="Consolas"/>
-                <a:ea typeface="Consolas"/>
-                <a:cs typeface="Consolas"/>
-              </a:rPr>
-              <a:t>interface</a:t>
-            </a:r>
-            <a:r>
-              <a:rPr sz="1120" b="0">
-                <a:solidFill>
-                  <a:srgbClr val="202632"/>
-                </a:solidFill>
-                <a:latin typeface="Consolas"/>
-                <a:ea typeface="Consolas"/>
-                <a:cs typeface="Consolas"/>
-              </a:rPr>
-              <a:t> </a:t>
-            </a:r>
-            <a:r>
-              <a:rPr sz="1120" b="1">
-                <a:solidFill>
-                  <a:srgbClr val="7F3FBF"/>
-                </a:solidFill>
-                <a:latin typeface="Consolas"/>
-                <a:ea typeface="Consolas"/>
-                <a:cs typeface="Consolas"/>
-              </a:rPr>
-              <a:t>IInventoryModule</a:t>
-            </a:r>
-            <a:br/>
-            <a:r>
-              <a:rPr sz="1120">
-                <a:solidFill>
-                  <a:srgbClr val="7A8699"/>
-                </a:solidFill>
-                <a:latin typeface="Consolas"/>
-                <a:ea typeface="Consolas"/>
-                <a:cs typeface="Consolas"/>
-              </a:rPr>
-              <a:t> 8  </a:t>
-            </a:r>
-            <a:r>
-              <a:rPr sz="1120" b="0">
-                <a:solidFill>
-                  <a:srgbClr val="202632"/>
-                </a:solidFill>
-                <a:latin typeface="Consolas"/>
-                <a:ea typeface="Consolas"/>
-                <a:cs typeface="Consolas"/>
-              </a:rPr>
-              <a:t>{</a:t>
-            </a:r>
-            <a:br/>
-            <a:r>
-              <a:rPr sz="1120">
-                <a:solidFill>
-                  <a:srgbClr val="7A8699"/>
-                </a:solidFill>
-                <a:latin typeface="Consolas"/>
-                <a:ea typeface="Consolas"/>
-                <a:cs typeface="Consolas"/>
-              </a:rPr>
-              <a:t> 9  </a:t>
-            </a:r>
-            <a:r>
-              <a:rPr sz="1120" b="0">
-                <a:solidFill>
-                  <a:srgbClr val="202632"/>
-                </a:solidFill>
-                <a:latin typeface="Consolas"/>
-                <a:ea typeface="Consolas"/>
-                <a:cs typeface="Consolas"/>
-              </a:rPr>
-              <a:t>  </a:t>
-            </a:r>
-            <a:r>
-              <a:rPr sz="1120" b="1">
-                <a:solidFill>
-                  <a:srgbClr val="7F3FBF"/>
-                </a:solidFill>
-                <a:latin typeface="Consolas"/>
-                <a:ea typeface="Consolas"/>
-                <a:cs typeface="Consolas"/>
-              </a:rPr>
-              <a:t>Task</a:t>
-            </a:r>
-            <a:r>
-              <a:rPr sz="1120" b="0">
-                <a:solidFill>
-                  <a:srgbClr val="202632"/>
-                </a:solidFill>
-                <a:latin typeface="Consolas"/>
-                <a:ea typeface="Consolas"/>
-                <a:cs typeface="Consolas"/>
-              </a:rPr>
-              <a:t>&lt;</a:t>
-            </a:r>
-            <a:r>
-              <a:rPr sz="1120" b="1">
-                <a:solidFill>
-                  <a:srgbClr val="7F3FBF"/>
-                </a:solidFill>
-                <a:latin typeface="Consolas"/>
-                <a:ea typeface="Consolas"/>
-                <a:cs typeface="Consolas"/>
-              </a:rPr>
-              <a:t>ReserveInventoryResult</a:t>
-            </a:r>
-            <a:r>
-              <a:rPr sz="1120" b="0">
-                <a:solidFill>
-                  <a:srgbClr val="202632"/>
-                </a:solidFill>
-                <a:latin typeface="Consolas"/>
-                <a:ea typeface="Consolas"/>
-                <a:cs typeface="Consolas"/>
-              </a:rPr>
-              <a:t>&gt; </a:t>
-            </a:r>
-            <a:r>
-              <a:rPr sz="1120" b="1">
-                <a:solidFill>
-                  <a:srgbClr val="7F3FBF"/>
-                </a:solidFill>
-                <a:latin typeface="Consolas"/>
-                <a:ea typeface="Consolas"/>
-                <a:cs typeface="Consolas"/>
-              </a:rPr>
-              <a:t>ReserveAsync</a:t>
-            </a:r>
-            <a:r>
-              <a:rPr sz="1120" b="0">
-                <a:solidFill>
-                  <a:srgbClr val="202632"/>
-                </a:solidFill>
-                <a:latin typeface="Consolas"/>
-                <a:ea typeface="Consolas"/>
-                <a:cs typeface="Consolas"/>
-              </a:rPr>
-              <a:t>(</a:t>
-            </a:r>
-            <a:br/>
-            <a:r>
-              <a:rPr sz="1120">
-                <a:solidFill>
-                  <a:srgbClr val="7A8699"/>
-                </a:solidFill>
-                <a:latin typeface="Consolas"/>
-                <a:ea typeface="Consolas"/>
-                <a:cs typeface="Consolas"/>
-              </a:rPr>
-              <a:t>10  </a:t>
-            </a:r>
-            <a:r>
-              <a:rPr sz="1120" b="0">
-                <a:solidFill>
-                  <a:srgbClr val="202632"/>
-                </a:solidFill>
-                <a:latin typeface="Consolas"/>
-                <a:ea typeface="Consolas"/>
-                <a:cs typeface="Consolas"/>
-              </a:rPr>
-              <a:t>    </a:t>
-            </a:r>
-            <a:r>
-              <a:rPr sz="1120" b="1">
-                <a:solidFill>
-                  <a:srgbClr val="7F3FBF"/>
-                </a:solidFill>
-                <a:latin typeface="Consolas"/>
-                <a:ea typeface="Consolas"/>
-                <a:cs typeface="Consolas"/>
-              </a:rPr>
-              <a:t>ReserveInventoryRequest</a:t>
-            </a:r>
-            <a:r>
-              <a:rPr sz="1120" b="0">
-                <a:solidFill>
-                  <a:srgbClr val="202632"/>
-                </a:solidFill>
-                <a:latin typeface="Consolas"/>
-                <a:ea typeface="Consolas"/>
-                <a:cs typeface="Consolas"/>
-              </a:rPr>
-              <a:t> request,</a:t>
-            </a:r>
-            <a:br/>
-            <a:r>
-              <a:rPr sz="1120">
-                <a:solidFill>
-                  <a:srgbClr val="7A8699"/>
-                </a:solidFill>
-                <a:latin typeface="Consolas"/>
-                <a:ea typeface="Consolas"/>
-                <a:cs typeface="Consolas"/>
-              </a:rPr>
               <a:t>11  </a:t>
-            </a:r>
-            <a:r>
-              <a:rPr sz="1120" b="0">
-                <a:solidFill>
-                  <a:srgbClr val="202632"/>
-                </a:solidFill>
-                <a:latin typeface="Consolas"/>
-                <a:ea typeface="Consolas"/>
-                <a:cs typeface="Consolas"/>
-              </a:rPr>
-              <a:t>    </a:t>
-            </a:r>
-            <a:r>
-              <a:rPr sz="1120" b="1">
-                <a:solidFill>
-                  <a:srgbClr val="7F3FBF"/>
-                </a:solidFill>
-                <a:latin typeface="Consolas"/>
-                <a:ea typeface="Consolas"/>
-                <a:cs typeface="Consolas"/>
-              </a:rPr>
-              <a:t>CancellationToken</a:t>
-            </a:r>
-            <a:r>
-              <a:rPr sz="1120" b="0">
-                <a:solidFill>
-                  <a:srgbClr val="202632"/>
-                </a:solidFill>
-                <a:latin typeface="Consolas"/>
-                <a:ea typeface="Consolas"/>
-                <a:cs typeface="Consolas"/>
-              </a:rPr>
-              <a:t> cancellationToken);</a:t>
-            </a:r>
-            <a:br/>
-            <a:r>
-              <a:rPr sz="1120">
-                <a:solidFill>
-                  <a:srgbClr val="7A8699"/>
-                </a:solidFill>
-                <a:latin typeface="Consolas"/>
-                <a:ea typeface="Consolas"/>
-                <a:cs typeface="Consolas"/>
-              </a:rPr>
-              <a:t>12  </a:t>
             </a:r>
             <a:r>
               <a:rPr sz="1120" b="0">

</xml_diff>